<commit_message>
Fase B (segunda ronda): deck, guía, README y changelog
- Slide 5 con cuatro condiciones de no liberación; slide 1 sin espacio vacío
- Cifras de 15 variables, holdout con baseline 5 % y AIR con intervalo
- Fuente verificada del rango 150-950 de DataCrédito con fecha de consulta

Co-Authored-By: Claude Fable 5.1 <noreply@anthropic.com>
</commit_message>
<xml_diff>
--- a/entregables/BancoW_Priorizacion_Renovaciones_DavinsonArteaga.pptx
+++ b/entregables/BancoW_Priorizacion_Renovaciones_DavinsonArteaga.pptx
@@ -113,37 +113,37 @@
   <p:extLst>
     <p:ext uri="{521415D9-36F7-43E2-AB2F-B90AF26B5E84}">
       <p14:sectionLst xmlns:p14="http://schemas.microsoft.com/office/powerpoint/2010/main">
-        <p14:section name="Decisión" id="{e4c02c71-ceda-7b49-74e9-8e2f8530038e}">
+        <p14:section name="Decisión" id="{e947533a-1f8c-ddc9-6a8d-dc7f84333afb}">
           <p14:sldIdLst>
             <p14:sldId id="256"/>
           </p14:sldIdLst>
         </p14:section>
-        <p14:section name="Datos" id="{ef1c5fd9-f216-731a-5277-e17ab4990be2}">
+        <p14:section name="Datos" id="{e80421bd-7d7d-c0a0-8877-68a39b68fed6}">
           <p14:sldIdLst>
             <p14:sldId id="257"/>
           </p14:sldIdLst>
         </p14:section>
-        <p14:section name="Alternativas" id="{7b7374ad-2f28-a385-5077-f8b384940cbb}">
+        <p14:section name="Alternativas" id="{22e6a8a1-7a02-047a-9b86-4cdcce09a56a}">
           <p14:sldIdLst>
             <p14:sldId id="258"/>
           </p14:sldIdLst>
         </p14:section>
-        <p14:section name="Valor" id="{ed4a0ec5-9aef-63dc-471b-782daca6fce7}">
+        <p14:section name="Valor" id="{6d5c723c-b6d9-03f2-6343-c404c537882d}">
           <p14:sldIdLst>
             <p14:sldId id="259"/>
           </p14:sldIdLst>
         </p14:section>
-        <p14:section name="Piloto" id="{e79aa1ad-e39c-6136-15b1-1bb2090ba871}">
+        <p14:section name="Piloto" id="{b121952c-9a25-e750-c985-3de904b0b9b1}">
           <p14:sldIdLst>
             <p14:sldId id="260"/>
           </p14:sldIdLst>
         </p14:section>
-        <p14:section name="Recomendación" id="{4c358d63-ed23-00cf-4b28-344bf50c8a6d}">
+        <p14:section name="Recomendación" id="{746314d4-711a-3af3-61a3-83cd38e026d5}">
           <p14:sldIdLst>
             <p14:sldId id="261"/>
           </p14:sldIdLst>
         </p14:section>
-        <p14:section name="Anexo" id="{97888735-91ed-4517-c918-b6d390b0572b}">
+        <p14:section name="Anexo" id="{b2138efb-b2ad-2767-aee6-74243d776485}">
           <p14:sldIdLst>
             <p14:sldId id="262"/>
           </p14:sldIdLst>
@@ -254,7 +254,7 @@
                 <c:ptCount val="3"/>
                 <c:lvl>
                   <c:pt idx="0">
-                    <c:v>16 variables ex ante</c:v>
+                    <c:v>15 variables ex ante</c:v>
                   </c:pt>
                   <c:pt idx="1">
                     <c:v>+ resultado_gestion_30d</c:v>
@@ -1206,7 +1206,7 @@
           <a:p>
             <a:r>
               <a:rPr lang="en-US" dirty="0"/>
-              <a:t>Detalle de cada hallazgo en la guía P5 y P6. Fuga: 78 % de «Acepta» renueva; dias_hasta_renovacion es nulo exactamente en los 1.436 no renovados. Calidad: max_mora_6m = −4, ahorro −350.000, contacto fechado 2026-09-15 con corte agosto; score de buró 352–912 está dentro de la escala DataCrédito 150–950 (confirmar central, versión y vigencia). contactabilidad_score no predice el contacto (32 % de no contactados en todos los cuartiles). cuotas_pagadas_pct y monto_preaprobado quedan fuera del set limpio hasta certificar su timestamp: no cuesta señal (AUC 0,52–0,53). Accuracy trivial: 79,8 % en la base, 96,4 % en producción sin acertar un renovador.</a:t>
+              <a:t>Detalle de cada hallazgo en la guía P5 y P6. Fuga: 78 % de «Acepta» renueva; dias_hasta_renovacion es nulo exactamente en los 1.436 no renovados. Calidad: max_mora_6m = −4, ahorro −350.000, contacto fechado 2026-09-15 con corte agosto; score de buró 352–912 está dentro de la escala DataCrédito 150–950 (confirmar central, versión y vigencia). contactabilidad_score no predice el contacto (32 % de no contactados en todos los cuartiles). cuotas_pagadas_pct, monto_preaprobado y dias_ultimo_contacto quedan fuera del set limpio hasta certificar su timestamp (51 contactos fechados dentro del mes de corte y 1 después): no cuesta señal (AUC univariado 0,50–0,53); en producción se recalcula a la fecha de corte. Accuracy trivial: 79,8 % en la base, 96,4 % en producción sin acertar un renovador.</a:t>
             </a:r>
             <a:endParaRPr lang="en-US" dirty="0"/>
           </a:p>
@@ -1294,7 +1294,7 @@
           <a:p>
             <a:r>
               <a:rPr lang="en-US" dirty="0"/>
-              <a:t>Repliqué con la base: el AUC de C (0,94) solo se obtiene incluyendo el resultado de gestión; con dias_hasta_renovacion llega a 1,00. A: 0,86 supera lo que esta base permite replicar (0,82), pero la hoja viene de otra población, así que no es concluyente; su mora 7,2 % es la peor y, de ser real, lo convierte en la alternativa de menor valor; ambas cosas exigen auditoría variable por variable. B: coherente con la réplica, calibrado (pendiente 0,90), estable; pasa a piloto tras la misma ficha de fuga. D: la hoja reporta «+3,1 pp incremental» en la columna de mora y Qini en la de PR-AUC; no es comparable con A, B y C sin aclarar unidades. Las conversiones «top 8k» de la hoja y la conversión top 32 % de la réplica (≈ 45 %) no son comparables: otra población y otra regla de contacto.</a:t>
+              <a:t>Repliqué con la base: el AUC de C (0,94) solo se obtiene incluyendo el resultado de gestión; con dias_hasta_renovacion llega a 1,00. A: 0,86 supera lo que esta base permite replicar (0,82), pero la hoja viene de otra población, así que no es concluyente; su mora 7,2 % es la peor y, de ser real, lo convierte en la alternativa de menor valor; ambas cosas exigen auditoría variable por variable. B: coherente con la réplica, calibrado (pendiente 0,91), estable; pasa a piloto tras la misma ficha de fuga. D: la hoja reporta «+3,1 pp incremental» en la columna de mora y Qini en la de PR-AUC; no es comparable con A, B y C sin aclarar unidades. Las conversiones «top 8k» de la hoja y la conversión top 32 % de la réplica (≈ 45 %) no son comparables: otra población y otra regla de contacto.</a:t>
             </a:r>
             <a:endParaRPr lang="en-US" dirty="0"/>
           </a:p>
@@ -1382,7 +1382,7 @@
           <a:p>
             <a:r>
               <a:rPr lang="en-US" dirty="0"/>
-              <a:t>B gana por riesgo, no por conversión: cada renovación de B vale 337.200 frente a 290.400 de A. Incertidumbre (supuesto 8.000 contactos por alternativa, 752 y 704 renovados): conversión z = 1,32 (p 0,19), mora z = 2,11 (p 0,03); en valor B es al menos equivalente dentro de la incertidumbre. El valor no es incremental: por eso el piloto. Capacidad: un ranking global sobrecarga Centro, Norte y Eje y deja ≈ 400 cupos ociosos en Suroccidente y Oriente; cuotas por regional con transferencia por valor marginal (tope a pactar con Comercial). La conversión en muestra con y sin cuotas es equivalente (43,2 % vs. 42,6 %, dentro del ruido). Sensibilidad a la pérdida por mora de 1,0 / 1,8 / 2,5 / 3,5 M: B 263 / 237 / 215 / 182 vs. A 262 / 218 / 181 / 126.</a:t>
+              <a:t>B gana por riesgo, no por conversión: cada renovación de B vale 337.200 frente a 290.400 de A. Incertidumbre (supuesto 8.000 contactos por alternativa, 752 y 704 renovados): conversión z = 1,32 (p 0,19), mora z = 2,11 (p 0,03); en valor B es al menos equivalente dentro de la incertidumbre. El valor no es incremental: el orgánico del tercil alto de buró (de donde sale el top de B) es ≈ 5 % (7 de 129 no contactados renovaron solos; IC 2,7–10,8 %), así que ≈ 57 % de las renovaciones de B serían orgánicas y el valor incremental ≈ 103 M (129 M con orgánico 4 %, 76 M con 6 %). Por eso el piloto. Capacidad: un ranking global sobrecarga Centro, Norte y Eje y deja ≈ 400 cupos ociosos en Suroccidente y Oriente; cuotas por regional con transferencia por valor marginal (tope a pactar con Comercial). La conversión en muestra con y sin cuotas es equivalente (41,9 % vs. 43,5 %, cuatro renovaciones de diferencia, dentro del ruido). Sensibilidad a la pérdida por mora de 1,0 / 1,8 / 2,5 / 3,5 M: B 263 / 237 / 215 / 182 vs. A 262 / 218 / 181 / 126.</a:t>
             </a:r>
             <a:endParaRPr lang="en-US" dirty="0"/>
           </a:p>
@@ -1470,7 +1470,7 @@
           <a:p>
             <a:r>
               <a:rPr lang="en-US" dirty="0"/>
-              <a:t>Mecánica: el universo elegible del mes (filtrado por el mismo piso de riesgo: corte de buró y max_mora pactados con Riesgos) se parte al azar en dos pools por cliente, estratificando por regional y tercil de score. El champion elige sus 4.000 en su pool; el challenger rankea el suyo, toma su top 4.800, retiene 800 al azar como holdout sin contacto y contacta 4.000. Capacidad intacta: 8.000. Dos reglas separadas: calidad de lista (challenger vs. champion) y efecto del contacto (challenger contactado vs. holdout). Potencia del holdout (800 vs. 4.000): uplift +1,2 pp exige 2,4 meses; +1,7 pp, 1,3 meses; +2,2 pp, 0,9. Costo de oportunidad 3,2 / 4,6 / 5,9 / 7,3 M/mes, ≤ 2 % del VE de B. Limitación: sin holdout en el champion no comparamos la incrementalidad de las dos políticas; la opción de 400 de holdout en el champion cuesta ≈ 2,3 M/mes y deja ese brazo en 3.600. Probar mora 5,1 % vs. 7,2 % exigiría 2.053 renovados por brazo: el riesgo entra por política y se vigila por vintage. Duración: dos meses de asignación + 30 días de ventana + 30 a 60 de maduración; decisión a los 90 días. Jerga (SRM, CSI, Brier, CUPED) en el anexo y la guía. Condiciones completas de no liberación en la guía P16.</a:t>
+              <a:t>Mecánica: el universo elegible del mes (filtrado por el mismo piso de riesgo: corte de buró y max_mora pactados con Riesgos) se parte al azar en dos pools por cliente, estratificando por regional y tercil de score. El champion elige sus 4.000 en su pool; el challenger rankea el suyo, toma su top 4.800, retiene 800 al azar como holdout sin contacto y contacta 4.000. Capacidad intacta: 8.000. Dos reglas separadas: calidad de lista (challenger vs. champion) y efecto del contacto (challenger contactado vs. holdout). Baseline del holdout: no el 2,3 % global, sino el orgánico del tercil alto de buró (≈ 5 %, 7 de 129, IC 2,7–10,8 %), porque el holdout sale del top de B. Potencia (800 vs. 4.000, baseline 5 %): conservador +1,7 pp exige 1.856 en holdout, 2,3 meses, 4,6 M/mes de costo; plausible +3,8 pp (el uplift implícito si B convierte 8,8 % sobre un orgánico de 5 %) exige 444, 0,6 meses, 10,3 M/mes. Dos meses detectan el escenario plausible con margen; el conservador necesita un tercer mes. El costo es ≤ 4 % del VE de B. Limitación: sin holdout en el champion no comparamos la incrementalidad de las dos políticas; la opción de 400 de holdout en el champion cuesta ≈ 2,3 M/mes y deja ese brazo en 3.600. Probar mora 5,1 % vs. 7,2 % exigiría 2.053 renovados por brazo: el riesgo entra por política y se vigila por vintage. Duración: dos meses de asignación + 30 días de ventana + 30 a 60 de maduración; decisión a los 90 días. Jerga (SRM, CSI, Brier, CUPED) en el anexo y la guía. Condiciones completas de no liberación en la guía P16.</a:t>
             </a:r>
             <a:endParaRPr lang="en-US" dirty="0"/>
           </a:p>
@@ -1558,7 +1558,7 @@
           <a:p>
             <a:r>
               <a:rPr lang="en-US" dirty="0"/>
-              <a:t>Pedimos tres decisiones. Ruta de 90 días con la ficha de fuga variable por variable para A y B en las semanas 3 a 4 (fuente, timestamp, disponibilidad al puntuar). Gobierno: sin cuotas, el modelo limpio selecciona 28 % en Oriente frente a 35 % en Centro (AIR ≈ 0,80, en el límite); con cuotas, la selección por regional la fija la capacidad, así que la equidad se vigila en conversión y calibración por grupo dentro de cada regional. El 79 % de la lista cae en el tercil alto de buró: ese piso lo fija la política de riesgo, no el algoritmo. SHAP es correlación: en la base, 37 % del tercil bajo de buró quedó sin contactar frente a 22 % del alto.</a:t>
+              <a:t>Pedimos tres decisiones. Ruta de 90 días con la ficha de fuga variable por variable para A y B en las semanas 3 a 4 (fuente, timestamp, disponibilidad al puntuar). Gobierno: sin cuotas, el modelo limpio selecciona 28 % en Oriente frente a 35 % en Centro (AIR ≈ 0,80 puntual, pero con 100 a 200 clientes por regional el intervalo bootstrap es 0,49–0,88: el 0,80 no informa y el 0,67 de la partición sin gap cae dentro; la regla está pensada para el universo mensual de 25.000, donde el intervalo se estrecha unas seis veces); con cuotas, la selección por regional la fija la capacidad, así que la equidad se vigila en conversión y calibración por grupo dentro de cada regional. El 79 % de la lista cae en el tercil alto de buró: ese piso lo fija la política de riesgo, no el algoritmo. SHAP es correlación: en la base, 37 % del tercil bajo de buró quedó sin contactar frente a 22 % del alto.</a:t>
             </a:r>
             <a:endParaRPr lang="en-US" dirty="0"/>
           </a:p>
@@ -2329,11 +2329,11 @@
         <p:spPr>
           <a:xfrm>
             <a:off x="457200" y="1325880"/>
-            <a:ext cx="3611880" cy="1554480"/>
+            <a:ext cx="3611880" cy="1691640"/>
           </a:xfrm>
           <a:prstGeom prst="roundRect">
             <a:avLst>
-              <a:gd name="adj" fmla="val 7059"/>
+              <a:gd name="adj" fmla="val 6486"/>
             </a:avLst>
           </a:prstGeom>
           <a:solidFill>
@@ -2434,7 +2434,7 @@
         <p:spPr>
           <a:xfrm>
             <a:off x="621792" y="2286000"/>
-            <a:ext cx="3282696" cy="502920"/>
+            <a:ext cx="3282696" cy="640080"/>
           </a:xfrm>
           <a:prstGeom prst="rect">
             <a:avLst/>
@@ -2473,11 +2473,11 @@
         <p:spPr>
           <a:xfrm>
             <a:off x="4288536" y="1325880"/>
-            <a:ext cx="3611880" cy="1554480"/>
+            <a:ext cx="3611880" cy="1691640"/>
           </a:xfrm>
           <a:prstGeom prst="roundRect">
             <a:avLst>
-              <a:gd name="adj" fmla="val 7059"/>
+              <a:gd name="adj" fmla="val 6486"/>
             </a:avLst>
           </a:prstGeom>
           <a:solidFill>
@@ -2578,7 +2578,7 @@
         <p:spPr>
           <a:xfrm>
             <a:off x="4453128" y="2286000"/>
-            <a:ext cx="3282696" cy="502920"/>
+            <a:ext cx="3282696" cy="640080"/>
           </a:xfrm>
           <a:prstGeom prst="rect">
             <a:avLst/>
@@ -2617,11 +2617,11 @@
         <p:spPr>
           <a:xfrm>
             <a:off x="8119872" y="1325880"/>
-            <a:ext cx="3611880" cy="1554480"/>
+            <a:ext cx="3611880" cy="1691640"/>
           </a:xfrm>
           <a:prstGeom prst="roundRect">
             <a:avLst>
-              <a:gd name="adj" fmla="val 7059"/>
+              <a:gd name="adj" fmla="val 6486"/>
             </a:avLst>
           </a:prstGeom>
           <a:solidFill>
@@ -2722,7 +2722,7 @@
         <p:spPr>
           <a:xfrm>
             <a:off x="8284464" y="2286000"/>
-            <a:ext cx="3282696" cy="502920"/>
+            <a:ext cx="3282696" cy="640080"/>
           </a:xfrm>
           <a:prstGeom prst="rect">
             <a:avLst/>
@@ -2760,8 +2760,8 @@
         </p:nvSpPr>
         <p:spPr>
           <a:xfrm>
-            <a:off x="457200" y="3291840"/>
-            <a:ext cx="6035040" cy="2926080"/>
+            <a:off x="457200" y="3520440"/>
+            <a:ext cx="6035040" cy="2834640"/>
           </a:xfrm>
           <a:prstGeom prst="rect">
             <a:avLst/>
@@ -2775,13 +2775,13 @@
           <a:p>
             <a:pPr marL="177800" indent="-177800">
               <a:spcAft>
-                <a:spcPts val="800"/>
+                <a:spcPts val="3000"/>
               </a:spcAft>
               <a:buSzPct val="100000"/>
               <a:buChar char="•"/>
             </a:pPr>
             <a:r>
-              <a:rPr lang="en-US" sz="1250" b="1" dirty="0">
+              <a:rPr lang="en-US" sz="1400" b="1" dirty="0">
                 <a:solidFill>
                   <a:srgbClr val="043F52"/>
                 </a:solidFill>
@@ -2793,12 +2793,12 @@
             </a:r>
             <a:pPr indent="0" marL="0">
               <a:spcAft>
-                <a:spcPts val="800"/>
+                <a:spcPts val="3000"/>
               </a:spcAft>
               <a:buNone/>
             </a:pPr>
             <a:r>
-              <a:rPr lang="en-US" sz="1250" dirty="0">
+              <a:rPr lang="en-US" sz="1400" dirty="0">
                 <a:solidFill>
                   <a:srgbClr val="043F52"/>
                 </a:solidFill>
@@ -2808,18 +2808,18 @@
               </a:rPr>
               <a:t>los 8.000 de mayor valor incremental neto.</a:t>
             </a:r>
-            <a:endParaRPr lang="en-US" sz="1250" dirty="0"/>
+            <a:endParaRPr lang="en-US" sz="1400" dirty="0"/>
           </a:p>
           <a:p>
             <a:pPr marL="177800" indent="-177800">
               <a:spcAft>
-                <a:spcPts val="800"/>
+                <a:spcPts val="3000"/>
               </a:spcAft>
               <a:buSzPct val="100000"/>
               <a:buChar char="•"/>
             </a:pPr>
             <a:r>
-              <a:rPr lang="en-US" sz="1250" b="1" dirty="0">
+              <a:rPr lang="en-US" sz="1400" b="1" dirty="0">
                 <a:solidFill>
                   <a:srgbClr val="043F52"/>
                 </a:solidFill>
@@ -2831,12 +2831,12 @@
             </a:r>
             <a:pPr indent="0" marL="0">
               <a:spcAft>
-                <a:spcPts val="800"/>
+                <a:spcPts val="3000"/>
               </a:spcAft>
               <a:buNone/>
             </a:pPr>
             <a:r>
-              <a:rPr lang="en-US" sz="1250" dirty="0">
+              <a:rPr lang="en-US" sz="1400" dirty="0">
                 <a:solidFill>
                   <a:srgbClr val="043F52"/>
                 </a:solidFill>
@@ -2846,18 +2846,18 @@
               </a:rPr>
               <a:t>propensión calibrada × riesgo × valor; uplift a mediano plazo.</a:t>
             </a:r>
-            <a:endParaRPr lang="en-US" sz="1250" dirty="0"/>
+            <a:endParaRPr lang="en-US" sz="1400" dirty="0"/>
           </a:p>
           <a:p>
             <a:pPr marL="177800" indent="-177800">
               <a:spcAft>
-                <a:spcPts val="800"/>
+                <a:spcPts val="3000"/>
               </a:spcAft>
               <a:buSzPct val="100000"/>
               <a:buChar char="•"/>
             </a:pPr>
             <a:r>
-              <a:rPr lang="en-US" sz="1250" b="1" dirty="0">
+              <a:rPr lang="en-US" sz="1400" b="1" dirty="0">
                 <a:solidFill>
                   <a:srgbClr val="043F52"/>
                 </a:solidFill>
@@ -2869,12 +2869,12 @@
             </a:r>
             <a:pPr indent="0" marL="0">
               <a:spcAft>
-                <a:spcPts val="800"/>
+                <a:spcPts val="3000"/>
               </a:spcAft>
               <a:buNone/>
             </a:pPr>
             <a:r>
-              <a:rPr lang="en-US" sz="1250" dirty="0">
+              <a:rPr lang="en-US" sz="1400" dirty="0">
                 <a:solidFill>
                   <a:srgbClr val="043F52"/>
                 </a:solidFill>
@@ -2884,18 +2884,18 @@
               </a:rPr>
               <a:t>denominador, ventana, orgánicas (2,3 % renovó solo).</a:t>
             </a:r>
-            <a:endParaRPr lang="en-US" sz="1250" dirty="0"/>
+            <a:endParaRPr lang="en-US" sz="1400" dirty="0"/>
           </a:p>
           <a:p>
             <a:pPr marL="177800" indent="-177800">
               <a:spcAft>
-                <a:spcPts val="800"/>
+                <a:spcPts val="3000"/>
               </a:spcAft>
               <a:buSzPct val="100000"/>
               <a:buChar char="•"/>
             </a:pPr>
             <a:r>
-              <a:rPr lang="en-US" sz="1250" b="1" dirty="0">
+              <a:rPr lang="en-US" sz="1400" b="1" dirty="0">
                 <a:solidFill>
                   <a:srgbClr val="043F52"/>
                 </a:solidFill>
@@ -2907,12 +2907,12 @@
             </a:r>
             <a:pPr indent="0" marL="0">
               <a:spcAft>
-                <a:spcPts val="800"/>
+                <a:spcPts val="3000"/>
               </a:spcAft>
               <a:buNone/>
             </a:pPr>
             <a:r>
-              <a:rPr lang="en-US" sz="1250" dirty="0">
+              <a:rPr lang="en-US" sz="1400" dirty="0">
                 <a:solidFill>
                   <a:srgbClr val="043F52"/>
                 </a:solidFill>
@@ -2922,7 +2922,7 @@
               </a:rPr>
               <a:t>¿cómo se eligió a quién contactar y qué pasó con el resto?</a:t>
             </a:r>
-            <a:endParaRPr lang="en-US" sz="1250" dirty="0"/>
+            <a:endParaRPr lang="en-US" sz="1400" dirty="0"/>
           </a:p>
         </p:txBody>
       </p:sp>
@@ -2934,12 +2934,12 @@
         </p:nvSpPr>
         <p:spPr>
           <a:xfrm>
-            <a:off x="6766560" y="3291840"/>
-            <a:ext cx="4965192" cy="960120"/>
+            <a:off x="6766560" y="3429000"/>
+            <a:ext cx="4965192" cy="1097280"/>
           </a:xfrm>
           <a:prstGeom prst="roundRect">
             <a:avLst>
-              <a:gd name="adj" fmla="val 9524"/>
+              <a:gd name="adj" fmla="val 8333"/>
             </a:avLst>
           </a:prstGeom>
           <a:solidFill>
@@ -2961,8 +2961,8 @@
         </p:nvSpPr>
         <p:spPr>
           <a:xfrm>
-            <a:off x="6903720" y="3337560"/>
-            <a:ext cx="4709160" cy="886968"/>
+            <a:off x="6903720" y="3474720"/>
+            <a:ext cx="4709160" cy="1005840"/>
           </a:xfrm>
           <a:prstGeom prst="rect">
             <a:avLst/>
@@ -2978,7 +2978,7 @@
               <a:buNone/>
             </a:pPr>
             <a:r>
-              <a:rPr lang="en-US" sz="1100" b="1" dirty="0">
+              <a:rPr lang="en-US" sz="1200" b="1" dirty="0">
                 <a:solidFill>
                   <a:srgbClr val="043F52"/>
                 </a:solidFill>
@@ -2992,7 +2992,7 @@
               <a:buNone/>
             </a:pPr>
             <a:r>
-              <a:rPr lang="en-US" sz="1100" dirty="0">
+              <a:rPr lang="en-US" sz="1200" dirty="0">
                 <a:solidFill>
                   <a:srgbClr val="043F52"/>
                 </a:solidFill>
@@ -3006,7 +3006,7 @@
               <a:buNone/>
             </a:pPr>
             <a:r>
-              <a:rPr lang="en-US" sz="1100" b="1" dirty="0">
+              <a:rPr lang="en-US" sz="1200" b="1" dirty="0">
                 <a:solidFill>
                   <a:srgbClr val="043F52"/>
                 </a:solidFill>
@@ -3020,7 +3020,7 @@
               <a:buNone/>
             </a:pPr>
             <a:r>
-              <a:rPr lang="en-US" sz="1100" dirty="0">
+              <a:rPr lang="en-US" sz="1200" dirty="0">
                 <a:solidFill>
                   <a:srgbClr val="043F52"/>
                 </a:solidFill>
@@ -3030,7 +3030,7 @@
               </a:rPr>
               <a:t>incrementales por 1.000 contactos.</a:t>
             </a:r>
-            <a:endParaRPr lang="en-US" sz="1100" dirty="0"/>
+            <a:endParaRPr lang="en-US" sz="1200" dirty="0"/>
           </a:p>
         </p:txBody>
       </p:sp>
@@ -3042,8 +3042,8 @@
         </p:nvSpPr>
         <p:spPr>
           <a:xfrm>
-            <a:off x="6766560" y="4434840"/>
-            <a:ext cx="4965192" cy="1828800"/>
+            <a:off x="6766560" y="4754880"/>
+            <a:ext cx="4965192" cy="1645920"/>
           </a:xfrm>
           <a:prstGeom prst="rect">
             <a:avLst/>
@@ -3057,13 +3057,13 @@
           <a:p>
             <a:pPr marL="177800" indent="-177800">
               <a:spcAft>
-                <a:spcPts val="400"/>
+                <a:spcPts val="900"/>
               </a:spcAft>
               <a:buSzPct val="100000"/>
               <a:buChar char="•"/>
             </a:pPr>
             <a:r>
-              <a:rPr lang="en-US" sz="1150" b="1" dirty="0">
+              <a:rPr lang="en-US" sz="1200" b="1" dirty="0">
                 <a:solidFill>
                   <a:srgbClr val="043F52"/>
                 </a:solidFill>
@@ -3075,12 +3075,12 @@
             </a:r>
             <a:pPr indent="0" marL="0">
               <a:spcAft>
-                <a:spcPts val="400"/>
+                <a:spcPts val="900"/>
               </a:spcAft>
               <a:buNone/>
             </a:pPr>
             <a:r>
-              <a:rPr lang="en-US" sz="1150" dirty="0">
+              <a:rPr lang="en-US" sz="1200" dirty="0">
                 <a:solidFill>
                   <a:srgbClr val="043F52"/>
                 </a:solidFill>
@@ -3090,18 +3090,18 @@
               </a:rPr>
               <a:t>mora esperada de la lista ≤ umbral pactado antes (veto).</a:t>
             </a:r>
-            <a:endParaRPr lang="en-US" sz="1150" dirty="0"/>
+            <a:endParaRPr lang="en-US" sz="1200" dirty="0"/>
           </a:p>
           <a:p>
             <a:pPr marL="177800" indent="-177800">
               <a:spcAft>
-                <a:spcPts val="400"/>
+                <a:spcPts val="900"/>
               </a:spcAft>
               <a:buSzPct val="100000"/>
               <a:buChar char="•"/>
             </a:pPr>
             <a:r>
-              <a:rPr lang="en-US" sz="1150" b="1" dirty="0">
+              <a:rPr lang="en-US" sz="1200" b="1" dirty="0">
                 <a:solidFill>
                   <a:srgbClr val="043F52"/>
                 </a:solidFill>
@@ -3113,12 +3113,12 @@
             </a:r>
             <a:pPr indent="0" marL="0">
               <a:spcAft>
-                <a:spcPts val="400"/>
+                <a:spcPts val="900"/>
               </a:spcAft>
               <a:buNone/>
             </a:pPr>
             <a:r>
-              <a:rPr lang="en-US" sz="1150" dirty="0">
+              <a:rPr lang="en-US" sz="1200" dirty="0">
                 <a:solidFill>
                   <a:srgbClr val="043F52"/>
                 </a:solidFill>
@@ -3128,18 +3128,18 @@
               </a:rPr>
               <a:t>quejas y opt-out por 1.000 no peores (veto).</a:t>
             </a:r>
-            <a:endParaRPr lang="en-US" sz="1150" dirty="0"/>
+            <a:endParaRPr lang="en-US" sz="1200" dirty="0"/>
           </a:p>
           <a:p>
             <a:pPr marL="177800" indent="-177800">
               <a:spcAft>
-                <a:spcPts val="400"/>
+                <a:spcPts val="900"/>
               </a:spcAft>
               <a:buSzPct val="100000"/>
               <a:buChar char="•"/>
             </a:pPr>
             <a:r>
-              <a:rPr lang="en-US" sz="1150" b="1" dirty="0">
+              <a:rPr lang="en-US" sz="1200" b="1" dirty="0">
                 <a:solidFill>
                   <a:srgbClr val="043F52"/>
                 </a:solidFill>
@@ -3151,12 +3151,12 @@
             </a:r>
             <a:pPr indent="0" marL="0">
               <a:spcAft>
-                <a:spcPts val="400"/>
+                <a:spcPts val="900"/>
               </a:spcAft>
               <a:buNone/>
             </a:pPr>
             <a:r>
-              <a:rPr lang="en-US" sz="1150" dirty="0">
+              <a:rPr lang="en-US" sz="1200" dirty="0">
                 <a:solidFill>
                   <a:srgbClr val="043F52"/>
                 </a:solidFill>
@@ -3166,18 +3166,18 @@
               </a:rPr>
               <a:t>selección por regional y grupo ≥ 0,8 (alerta).</a:t>
             </a:r>
-            <a:endParaRPr lang="en-US" sz="1150" dirty="0"/>
+            <a:endParaRPr lang="en-US" sz="1200" dirty="0"/>
           </a:p>
           <a:p>
             <a:pPr marL="177800" indent="-177800">
               <a:spcAft>
-                <a:spcPts val="400"/>
+                <a:spcPts val="900"/>
               </a:spcAft>
               <a:buSzPct val="100000"/>
               <a:buChar char="•"/>
             </a:pPr>
             <a:r>
-              <a:rPr lang="en-US" sz="1150" b="1" dirty="0">
+              <a:rPr lang="en-US" sz="1200" b="1" dirty="0">
                 <a:solidFill>
                   <a:srgbClr val="043F52"/>
                 </a:solidFill>
@@ -3189,12 +3189,12 @@
             </a:r>
             <a:pPr indent="0" marL="0">
               <a:spcAft>
-                <a:spcPts val="400"/>
+                <a:spcPts val="900"/>
               </a:spcAft>
               <a:buNone/>
             </a:pPr>
             <a:r>
-              <a:rPr lang="en-US" sz="1150" dirty="0">
+              <a:rPr lang="en-US" sz="1200" dirty="0">
                 <a:solidFill>
                   <a:srgbClr val="043F52"/>
                 </a:solidFill>
@@ -3204,18 +3204,18 @@
               </a:rPr>
               <a:t>≥ 90 % de lista ejecutada (alerta).</a:t>
             </a:r>
-            <a:endParaRPr lang="en-US" sz="1150" dirty="0"/>
+            <a:endParaRPr lang="en-US" sz="1200" dirty="0"/>
           </a:p>
           <a:p>
             <a:pPr marL="177800" indent="-177800">
               <a:spcAft>
-                <a:spcPts val="400"/>
+                <a:spcPts val="900"/>
               </a:spcAft>
               <a:buSzPct val="100000"/>
               <a:buChar char="•"/>
             </a:pPr>
             <a:r>
-              <a:rPr lang="en-US" sz="1150" b="1" dirty="0">
+              <a:rPr lang="en-US" sz="1200" b="1" dirty="0">
                 <a:solidFill>
                   <a:srgbClr val="043F52"/>
                 </a:solidFill>
@@ -3227,12 +3227,12 @@
             </a:r>
             <a:pPr indent="0" marL="0">
               <a:spcAft>
-                <a:spcPts val="400"/>
+                <a:spcPts val="900"/>
               </a:spcAft>
               <a:buNone/>
             </a:pPr>
             <a:r>
-              <a:rPr lang="en-US" sz="1150" dirty="0">
+              <a:rPr lang="en-US" sz="1200" dirty="0">
                 <a:solidFill>
                   <a:srgbClr val="043F52"/>
                 </a:solidFill>
@@ -3242,7 +3242,7 @@
               </a:rPr>
               <a:t>aleatorización y datos válidos (bloqueo).</a:t>
             </a:r>
-            <a:endParaRPr lang="en-US" sz="1150" dirty="0"/>
+            <a:endParaRPr lang="en-US" sz="1200" dirty="0"/>
           </a:p>
         </p:txBody>
       </p:sp>
@@ -9025,7 +9025,7 @@
                 <a:ea typeface="Calibri" pitchFamily="34" charset="-122"/>
                 <a:cs typeface="Calibri" pitchFamily="34" charset="-120"/>
               </a:rPr>
-              <a:t>No incremental: si la mitad de las 704 renovaciones de B fuera orgánica, baja a 119 M.</a:t>
+              <a:t>No incremental: con orgánico ≈ 5 % (57 % de las 704 renovaciones de B), el valor incremental baja a ≈ 103 M.</a:t>
             </a:r>
             <a:endParaRPr lang="en-US" sz="1100" dirty="0"/>
           </a:p>
@@ -10679,7 +10679,7 @@
                           <a:ea typeface="Calibri" pitchFamily="34" charset="-122"/>
                           <a:cs typeface="Calibri" pitchFamily="34" charset="-120"/>
                         </a:rPr>
-                        <a:t>Mayor valor marginal (86 k): recibe cupos transferidos</a:t>
+                        <a:t>Mayor valor marginal (85 k): recibe cupos transferidos</a:t>
                       </a:r>
                       <a:endParaRPr lang="en-US" sz="1050" dirty="0">
                         <a:latin typeface="Calibri" charset="0"/>
@@ -11071,7 +11071,7 @@
                           <a:ea typeface="Calibri" pitchFamily="34" charset="-122"/>
                           <a:cs typeface="Calibri" pitchFamily="34" charset="-120"/>
                         </a:rPr>
-                        <a:t>Corte por cuota; segundo valor marginal (81 k)</a:t>
+                        <a:t>Corte por cuota; segundo valor marginal (82 k)</a:t>
                       </a:r>
                       <a:endParaRPr lang="en-US" sz="1050" dirty="0">
                         <a:latin typeface="Calibri" charset="0"/>
@@ -11463,7 +11463,7 @@
                           <a:ea typeface="Calibri" pitchFamily="34" charset="-122"/>
                           <a:cs typeface="Calibri" pitchFamily="34" charset="-120"/>
                         </a:rPr>
-                        <a:t>Menor valor marginal (61 k): cede cupos, tope a pactar (10 %)</a:t>
+                        <a:t>Menor valor marginal (65 k): cede cupos, tope a pactar (10 %)</a:t>
                       </a:r>
                       <a:endParaRPr lang="en-US" sz="1050" dirty="0">
                         <a:latin typeface="Calibri" charset="0"/>
@@ -11696,7 +11696,7 @@
                 <a:ea typeface="Calibri" pitchFamily="34" charset="-122"/>
                 <a:cs typeface="Calibri" pitchFamily="34" charset="-120"/>
               </a:rPr>
-              <a:t>Diseño: dos pools al azar, mismo piso de riesgo</a:t>
+              <a:t>Diseño: dos pools al azar, mismo piso</a:t>
             </a:r>
             <a:endParaRPr lang="en-US" sz="1300" dirty="0"/>
           </a:p>
@@ -11801,7 +11801,7 @@
                 <a:ea typeface="Calibri" pitchFamily="34" charset="-122"/>
                 <a:cs typeface="Calibri" pitchFamily="34" charset="-120"/>
               </a:rPr>
-              <a:t>Herramienta actual elige sus 4.000 en su pool</a:t>
+              <a:t>Herramienta actual elige 4.000 en su pool</a:t>
             </a:r>
             <a:endParaRPr lang="en-US" sz="1200" dirty="0"/>
           </a:p>
@@ -11945,7 +11945,7 @@
                 <a:ea typeface="Calibri" pitchFamily="34" charset="-122"/>
                 <a:cs typeface="Calibri" pitchFamily="34" charset="-120"/>
               </a:rPr>
-              <a:t>B rankea su pool con cuotas; toma su top 4.800</a:t>
+              <a:t>B rankea su pool con cuotas; top 4.800</a:t>
             </a:r>
             <a:endParaRPr lang="en-US" sz="1200" dirty="0"/>
           </a:p>
@@ -12089,7 +12089,7 @@
                 <a:ea typeface="Calibri" pitchFamily="34" charset="-122"/>
                 <a:cs typeface="Calibri" pitchFamily="34" charset="-120"/>
               </a:rPr>
-              <a:t>800 al azar del top 4.800 de B, sin contacto</a:t>
+              <a:t>800 al azar del top de B, sin contacto</a:t>
             </a:r>
             <a:endParaRPr lang="en-US" sz="1200" dirty="0"/>
           </a:p>
@@ -12171,7 +12171,7 @@
                 <a:ea typeface="Calibri" pitchFamily="34" charset="-122"/>
                 <a:cs typeface="Calibri" pitchFamily="34" charset="-120"/>
               </a:rPr>
-              <a:t>Calidad de lista: </a:t>
+              <a:t>Calidad: </a:t>
             </a:r>
             <a:pPr indent="0" marL="0">
               <a:spcAft>
@@ -12188,7 +12188,7 @@
                 <a:ea typeface="Calibri" pitchFamily="34" charset="-122"/>
                 <a:cs typeface="Calibri" pitchFamily="34" charset="-120"/>
               </a:rPr>
-              <a:t>3,6 → 5,4 % se detecta con 2.081 por brazo (un mes); 3,6 → 4,5 %, dos meses.</a:t>
+              <a:t>3,6 → 5,4 % se detecta con 2.081 por brazo en un mes.</a:t>
             </a:r>
             <a:endParaRPr lang="en-US" sz="1100" dirty="0"/>
           </a:p>
@@ -12226,7 +12226,7 @@
                 <a:ea typeface="Calibri" pitchFamily="34" charset="-122"/>
                 <a:cs typeface="Calibri" pitchFamily="34" charset="-120"/>
               </a:rPr>
-              <a:t>uplift plausible 2,3 → 4,0 % (mitad del +3,1 pp de D) en 1,3 meses; cuesta 4,6 M/mes.</a:t>
+              <a:t>baseline 5 % (tercil alto); +3,8 pp en 0,6 meses, +1,7 pp en 2,3.</a:t>
             </a:r>
             <a:endParaRPr lang="en-US" sz="1100" dirty="0"/>
           </a:p>
@@ -12264,7 +12264,7 @@
                 <a:ea typeface="Calibri" pitchFamily="34" charset="-122"/>
                 <a:cs typeface="Calibri" pitchFamily="34" charset="-120"/>
               </a:rPr>
-              <a:t>el mismo piso en ambos brazos aísla el modelo; mora vigilada por vintage.</a:t>
+              <a:t>mismo piso en ambos brazos; vigilado por vintage.</a:t>
             </a:r>
             <a:endParaRPr lang="en-US" sz="1100" dirty="0"/>
           </a:p>
@@ -12302,7 +12302,7 @@
                 <a:ea typeface="Calibri" pitchFamily="34" charset="-122"/>
                 <a:cs typeface="Calibri" pitchFamily="34" charset="-120"/>
               </a:rPr>
-              <a:t>sin holdout en el champion no se compara su incrementalidad; opción, 400 allí (≈ 2,3 M/mes).</a:t>
+              <a:t>el champion sin holdout no mide su incrementalidad; opción, 400 allí (≈ 2,3 M/mes).</a:t>
             </a:r>
             <a:endParaRPr lang="en-US" sz="1100" dirty="0"/>
           </a:p>
@@ -13208,7 +13208,7 @@
                 <a:ea typeface="Calibri" pitchFamily="34" charset="-122"/>
                 <a:cs typeface="Calibri" pitchFamily="34" charset="-120"/>
               </a:rPr>
-              <a:t>Monitoreo, primeros tres meses</a:t>
+              <a:t>Monitoreo (tres meses)</a:t>
             </a:r>
             <a:endParaRPr lang="en-US" sz="1300" dirty="0"/>
           </a:p>
@@ -14681,7 +14681,7 @@
         <p:spPr>
           <a:xfrm>
             <a:off x="7589520" y="4937760"/>
-            <a:ext cx="4142232" cy="1280160"/>
+            <a:ext cx="4142232" cy="1417320"/>
           </a:xfrm>
           <a:prstGeom prst="rect">
             <a:avLst/>
@@ -14731,6 +14731,48 @@
                 <a:cs typeface="Calibri" pitchFamily="34" charset="-120"/>
               </a:rPr>
               <a:t>Sin calibración verificada, holdout, rollback o dueño.</a:t>
+            </a:r>
+            <a:endParaRPr lang="en-US" sz="1100" dirty="0"/>
+          </a:p>
+          <a:p>
+            <a:pPr marL="177800" indent="-177800">
+              <a:spcAft>
+                <a:spcPts val="200"/>
+              </a:spcAft>
+              <a:buSzPct val="100000"/>
+              <a:buChar char="•"/>
+            </a:pPr>
+            <a:r>
+              <a:rPr lang="en-US" sz="1100" dirty="0">
+                <a:solidFill>
+                  <a:srgbClr val="043F52"/>
+                </a:solidFill>
+                <a:latin typeface="Calibri" pitchFamily="34" charset="0"/>
+                <a:ea typeface="Calibri" pitchFamily="34" charset="-122"/>
+                <a:cs typeface="Calibri" pitchFamily="34" charset="-120"/>
+              </a:rPr>
+              <a:t>Capacidad que no ejecuta ≥ 90 % de la lista: el modelo no se prueba.</a:t>
+            </a:r>
+            <a:endParaRPr lang="en-US" sz="1100" dirty="0"/>
+          </a:p>
+          <a:p>
+            <a:pPr marL="177800" indent="-177800">
+              <a:spcAft>
+                <a:spcPts val="200"/>
+              </a:spcAft>
+              <a:buSzPct val="100000"/>
+              <a:buChar char="•"/>
+            </a:pPr>
+            <a:r>
+              <a:rPr lang="en-US" sz="1100" dirty="0">
+                <a:solidFill>
+                  <a:srgbClr val="043F52"/>
+                </a:solidFill>
+                <a:latin typeface="Calibri" pitchFamily="34" charset="0"/>
+                <a:ea typeface="Calibri" pitchFamily="34" charset="-122"/>
+                <a:cs typeface="Calibri" pitchFamily="34" charset="-120"/>
+              </a:rPr>
+              <a:t>Selección que excluye un grupo o regional sin explicación de negocio.</a:t>
             </a:r>
             <a:endParaRPr lang="en-US" sz="1100" dirty="0"/>
           </a:p>
@@ -16632,7 +16674,7 @@
                           <a:ea typeface="Calibri" pitchFamily="34" charset="-122"/>
                           <a:cs typeface="Calibri" pitchFamily="34" charset="-120"/>
                         </a:rPr>
-                        <a:t>16 ex ante limpias</a:t>
+                        <a:t>15 ex ante limpias</a:t>
                       </a:r>
                       <a:endParaRPr lang="en-US" sz="1050" dirty="0">
                         <a:latin typeface="Calibri" charset="0"/>
@@ -16762,7 +16804,7 @@
                           <a:ea typeface="Calibri" pitchFamily="34" charset="-122"/>
                           <a:cs typeface="Calibri" pitchFamily="34" charset="-120"/>
                         </a:rPr>
-                        <a:t>0,817</a:t>
+                        <a:t>0,820</a:t>
                       </a:r>
                       <a:endParaRPr lang="en-US" sz="1050" dirty="0">
                         <a:latin typeface="Calibri" charset="0"/>
@@ -16892,7 +16934,7 @@
                           <a:ea typeface="Calibri" pitchFamily="34" charset="-122"/>
                           <a:cs typeface="Calibri" pitchFamily="34" charset="-120"/>
                         </a:rPr>
-                        <a:t>0,52</a:t>
+                        <a:t>0,53</a:t>
                       </a:r>
                       <a:endParaRPr lang="en-US" sz="1050" dirty="0">
                         <a:latin typeface="Calibri" charset="0"/>
@@ -16957,7 +16999,7 @@
                           <a:ea typeface="Calibri" pitchFamily="34" charset="-122"/>
                           <a:cs typeface="Calibri" pitchFamily="34" charset="-120"/>
                         </a:rPr>
-                        <a:t>0,90</a:t>
+                        <a:t>0,91</a:t>
                       </a:r>
                       <a:endParaRPr lang="en-US" sz="1050" dirty="0">
                         <a:latin typeface="Calibri" charset="0"/>
@@ -17022,7 +17064,7 @@
                           <a:ea typeface="Calibri" pitchFamily="34" charset="-122"/>
                           <a:cs typeface="Calibri" pitchFamily="34" charset="-120"/>
                         </a:rPr>
-                        <a:t>0,130</a:t>
+                        <a:t>0,129</a:t>
                       </a:r>
                       <a:endParaRPr lang="en-US" sz="1050" dirty="0">
                         <a:latin typeface="Calibri" charset="0"/>
@@ -17089,7 +17131,7 @@
                           <a:ea typeface="Calibri" pitchFamily="34" charset="-122"/>
                           <a:cs typeface="Calibri" pitchFamily="34" charset="-120"/>
                         </a:rPr>
-                        <a:t>16 ex ante limpias</a:t>
+                        <a:t>15 ex ante limpias</a:t>
                       </a:r>
                       <a:endParaRPr lang="en-US" sz="1050" dirty="0">
                         <a:latin typeface="Calibri" charset="0"/>
@@ -17219,7 +17261,7 @@
                           <a:ea typeface="Calibri" pitchFamily="34" charset="-122"/>
                           <a:cs typeface="Calibri" pitchFamily="34" charset="-120"/>
                         </a:rPr>
-                        <a:t>0,786</a:t>
+                        <a:t>0,791</a:t>
                       </a:r>
                       <a:endParaRPr lang="en-US" sz="1050" dirty="0">
                         <a:latin typeface="Calibri" charset="0"/>
@@ -17284,7 +17326,7 @@
                           <a:ea typeface="Calibri" pitchFamily="34" charset="-122"/>
                           <a:cs typeface="Calibri" pitchFamily="34" charset="-120"/>
                         </a:rPr>
-                        <a:t>0,76–0,81</a:t>
+                        <a:t>0,77–0,82</a:t>
                       </a:r>
                       <a:endParaRPr lang="en-US" sz="1050" dirty="0">
                         <a:latin typeface="Calibri" charset="0"/>
@@ -17414,7 +17456,7 @@
                           <a:ea typeface="Calibri" pitchFamily="34" charset="-122"/>
                           <a:cs typeface="Calibri" pitchFamily="34" charset="-120"/>
                         </a:rPr>
-                        <a:t>0,77</a:t>
+                        <a:t>0,78</a:t>
                       </a:r>
                       <a:endParaRPr lang="en-US" sz="1050" dirty="0">
                         <a:latin typeface="Calibri" charset="0"/>
@@ -17479,7 +17521,7 @@
                           <a:ea typeface="Calibri" pitchFamily="34" charset="-122"/>
                           <a:cs typeface="Calibri" pitchFamily="34" charset="-120"/>
                         </a:rPr>
-                        <a:t>0,138</a:t>
+                        <a:t>0,137</a:t>
                       </a:r>
                       <a:endParaRPr lang="en-US" sz="1050" dirty="0">
                         <a:latin typeface="Calibri" charset="0"/>
@@ -17676,7 +17718,7 @@
                           <a:ea typeface="Calibri" pitchFamily="34" charset="-122"/>
                           <a:cs typeface="Calibri" pitchFamily="34" charset="-120"/>
                         </a:rPr>
-                        <a:t>0,819</a:t>
+                        <a:t>0,821</a:t>
                       </a:r>
                       <a:endParaRPr lang="en-US" sz="1050" dirty="0">
                         <a:latin typeface="Calibri" charset="0"/>
@@ -17741,7 +17783,7 @@
                           <a:ea typeface="Calibri" pitchFamily="34" charset="-122"/>
                           <a:cs typeface="Calibri" pitchFamily="34" charset="-120"/>
                         </a:rPr>
-                        <a:t>0,78–0,85</a:t>
+                        <a:t>0,79–0,85</a:t>
                       </a:r>
                       <a:endParaRPr lang="en-US" sz="1050" dirty="0">
                         <a:latin typeface="Calibri" charset="0"/>
@@ -17871,7 +17913,7 @@
                           <a:ea typeface="Calibri" pitchFamily="34" charset="-122"/>
                           <a:cs typeface="Calibri" pitchFamily="34" charset="-120"/>
                         </a:rPr>
-                        <a:t>0,90</a:t>
+                        <a:t>0,91</a:t>
                       </a:r>
                       <a:endParaRPr lang="en-US" sz="1050" dirty="0">
                         <a:latin typeface="Calibri" charset="0"/>
@@ -17936,7 +17978,7 @@
                           <a:ea typeface="Calibri" pitchFamily="34" charset="-122"/>
                           <a:cs typeface="Calibri" pitchFamily="34" charset="-120"/>
                         </a:rPr>
-                        <a:t>0,129</a:t>
+                        <a:t>0,128</a:t>
                       </a:r>
                       <a:endParaRPr lang="en-US" sz="1050" dirty="0">
                         <a:latin typeface="Calibri" charset="0"/>
@@ -18198,7 +18240,7 @@
                           <a:ea typeface="Calibri" pitchFamily="34" charset="-122"/>
                           <a:cs typeface="Calibri" pitchFamily="34" charset="-120"/>
                         </a:rPr>
-                        <a:t>0,93–0,96</a:t>
+                        <a:t>0,93–0,97</a:t>
                       </a:r>
                       <a:endParaRPr lang="en-US" sz="1050" dirty="0">
                         <a:latin typeface="Calibri" charset="0"/>
@@ -18911,8 +18953,8 @@
         </p:nvSpPr>
         <p:spPr>
           <a:xfrm>
-            <a:off x="457200" y="3108960"/>
-            <a:ext cx="6675120" cy="685800"/>
+            <a:off x="457200" y="3044952"/>
+            <a:ext cx="6675120" cy="777240"/>
           </a:xfrm>
           <a:prstGeom prst="rect">
             <a:avLst/>
@@ -18928,7 +18970,7 @@
               <a:buNone/>
             </a:pPr>
             <a:r>
-              <a:rPr lang="en-US" sz="900" dirty="0">
+              <a:rPr lang="en-US" sz="850" dirty="0">
                 <a:solidFill>
                   <a:srgbClr val="4A6A72"/>
                 </a:solidFill>
@@ -18936,9 +18978,9 @@
                 <a:ea typeface="Calibri" pitchFamily="34" charset="-122"/>
                 <a:cs typeface="Calibri" pitchFamily="34" charset="-120"/>
               </a:rPr>
-              <a:t>Prevalencia de la base 20,2 %. Calibración: pendiente de observado sobre predicho (1 = perfecta); media predicha 0,197 vs. observada 0,207. Las conversiones «top 8k» de la hoja no son comparables con esta base. Sin gap (train &lt; t, abril a agosto): 0,82 / 0,80; k-fold aleatorio: 0,82. Coeficientes estandarizados del modelo limpio: score_buro 1,30; max_mora_6m −0,56; respondio_oferta_previa 0,27; el resto &lt; 0,15.</a:t>
+              <a:t>Prevalencia de la base 20,2 %. Calibración: pendiente de observado sobre predicho (1 = perfecta); media predicha 0,197 vs. observada 0,207. Las conversiones «top 8k» de la hoja no son comparables con esta base. Sin gap (train &lt; t, abril a agosto): 0,82 / 0,80; k-fold aleatorio: 0,82. Coeficientes estandarizados del modelo limpio: score_buro 1,29; max_mora_6m −0,56; respondio_oferta_previa 0,27; el resto &lt; 0,15. Orgánico por tercil de buró (no contactados): alto 5,4 % (7/129, IC 2,7–10,8 %), contactados del tercil alto 53 %: parte del valor de B es orgánica y el holdout lo mide.</a:t>
             </a:r>
-            <a:endParaRPr lang="en-US" sz="900" dirty="0"/>
+            <a:endParaRPr lang="en-US" sz="850" dirty="0"/>
           </a:p>
         </p:txBody>
       </p:sp>
@@ -21486,8 +21528,8 @@
             <a:tbl>
               <a:tblPr/>
               <a:tblGrid>
-                <a:gridCol w="2103120"/>
-                <a:gridCol w="1691640"/>
+                <a:gridCol w="2240280"/>
+                <a:gridCol w="1554480"/>
                 <a:gridCol w="1417320"/>
               </a:tblGrid>
               <a:tr h="219456">
@@ -21779,7 +21821,7 @@
                           <a:ea typeface="Calibri" pitchFamily="34" charset="-122"/>
                           <a:cs typeface="Calibri" pitchFamily="34" charset="-120"/>
                         </a:rPr>
-                        <a:t>7.530 / 2.081 / 618 por brazo</a:t>
+                        <a:t>7.530 / 2.081 / 618 / brazo</a:t>
                       </a:r>
                       <a:endParaRPr lang="en-US" sz="1050" dirty="0">
                         <a:latin typeface="Calibri" charset="0"/>
@@ -22108,7 +22150,7 @@
                           <a:ea typeface="Calibri" pitchFamily="34" charset="-122"/>
                           <a:cs typeface="Calibri" pitchFamily="34" charset="-120"/>
                         </a:rPr>
-                        <a:t>Holdout 2,3 a 3,5 % (800 vs. 4.000)</a:t>
+                        <a:t>Holdout 5 %, +1,7 pp (conservador)</a:t>
                       </a:r>
                       <a:endParaRPr lang="en-US" sz="1050" dirty="0">
                         <a:latin typeface="Calibri" charset="0"/>
@@ -22173,7 +22215,7 @@
                           <a:ea typeface="Calibri" pitchFamily="34" charset="-122"/>
                           <a:cs typeface="Calibri" pitchFamily="34" charset="-120"/>
                         </a:rPr>
-                        <a:t>1.932 en holdout</a:t>
+                        <a:t>1.856 en holdout</a:t>
                       </a:r>
                       <a:endParaRPr lang="en-US" sz="1050" dirty="0">
                         <a:latin typeface="Calibri" charset="0"/>
@@ -22238,7 +22280,7 @@
                           <a:ea typeface="Calibri" pitchFamily="34" charset="-122"/>
                           <a:cs typeface="Calibri" pitchFamily="34" charset="-120"/>
                         </a:rPr>
-                        <a:t>2,4 meses · 3,2 M/mes</a:t>
+                        <a:t>2,3 meses · 4,6 M/mes</a:t>
                       </a:r>
                       <a:endParaRPr lang="en-US" sz="1050" dirty="0">
                         <a:latin typeface="Calibri" charset="0"/>
@@ -22305,7 +22347,7 @@
                           <a:ea typeface="Calibri" pitchFamily="34" charset="-122"/>
                           <a:cs typeface="Calibri" pitchFamily="34" charset="-120"/>
                         </a:rPr>
-                        <a:t>Holdout 2,3 a 4,0 % (plausible)</a:t>
+                        <a:t>Holdout 5 %, +3,8 pp (plausible, B)</a:t>
                       </a:r>
                       <a:endParaRPr lang="en-US" sz="1050" dirty="0">
                         <a:latin typeface="Calibri" charset="0"/>
@@ -22370,7 +22412,7 @@
                           <a:ea typeface="Calibri" pitchFamily="34" charset="-122"/>
                           <a:cs typeface="Calibri" pitchFamily="34" charset="-120"/>
                         </a:rPr>
-                        <a:t>1.056 en holdout</a:t>
+                        <a:t>444 en holdout</a:t>
                       </a:r>
                       <a:endParaRPr lang="en-US" sz="1050" dirty="0">
                         <a:latin typeface="Calibri" charset="0"/>
@@ -22435,7 +22477,7 @@
                           <a:ea typeface="Calibri" pitchFamily="34" charset="-122"/>
                           <a:cs typeface="Calibri" pitchFamily="34" charset="-120"/>
                         </a:rPr>
-                        <a:t>1,3 meses · 4,6 M/mes</a:t>
+                        <a:t>0,6 meses · 10,3 M/mes</a:t>
                       </a:r>
                       <a:endParaRPr lang="en-US" sz="1050" dirty="0">
                         <a:latin typeface="Calibri" charset="0"/>
@@ -22502,7 +22544,7 @@
                           <a:ea typeface="Calibri" pitchFamily="34" charset="-122"/>
                           <a:cs typeface="Calibri" pitchFamily="34" charset="-120"/>
                         </a:rPr>
-                        <a:t>Holdout 2,3 a 4,5 / 5,0 %</a:t>
+                        <a:t>Holdout 4 / 6 %, +2,5 pp</a:t>
                       </a:r>
                       <a:endParaRPr lang="en-US" sz="1050" dirty="0">
                         <a:latin typeface="Calibri" charset="0"/>
@@ -22567,7 +22609,7 @@
                           <a:ea typeface="Calibri" pitchFamily="34" charset="-122"/>
                           <a:cs typeface="Calibri" pitchFamily="34" charset="-120"/>
                         </a:rPr>
-                        <a:t>685 / 491 en holdout</a:t>
+                        <a:t>790 / 1.053 en holdout</a:t>
                       </a:r>
                       <a:endParaRPr lang="en-US" sz="1050" dirty="0">
                         <a:latin typeface="Calibri" charset="0"/>
@@ -22632,7 +22674,7 @@
                           <a:ea typeface="Calibri" pitchFamily="34" charset="-122"/>
                           <a:cs typeface="Calibri" pitchFamily="34" charset="-120"/>
                         </a:rPr>
-                        <a:t>0,9 / 0,6 m · 5,9 / 7,3 M</a:t>
+                        <a:t>1,0 / 1,3 m · 6,7 M/mes</a:t>
                       </a:r>
                       <a:endParaRPr lang="en-US" sz="1050" dirty="0">
                         <a:latin typeface="Calibri" charset="0"/>
@@ -23434,7 +23476,7 @@
                           <a:ea typeface="Calibri" pitchFamily="34" charset="-122"/>
                           <a:cs typeface="Calibri" pitchFamily="34" charset="-120"/>
                         </a:rPr>
-                        <a:t>fecha_ultimo_contacto (1 &gt; corte); cuotas_pagadas_pct, monto_preaprobado sin timestamp</a:t>
+                        <a:t>fecha_ultimo_contacto / dias_ultimo_contacto (51 en el mes, 1 &gt; corte); cuotas_pagadas_pct, monto_preaprobado</a:t>
                       </a:r>
                       <a:endParaRPr lang="en-US" sz="1050" dirty="0">
                         <a:latin typeface="Calibri" charset="0"/>
@@ -23499,7 +23541,7 @@
                           <a:ea typeface="Calibri" pitchFamily="34" charset="-122"/>
                           <a:cs typeface="Calibri" pitchFamily="34" charset="-120"/>
                         </a:rPr>
-                        <a:t>Fuera del set; sin costo (AUC 0,52–0,53); vuelven con timestamp</a:t>
+                        <a:t>Fuera del set; sin costo (AUC 0,50–0,53); vuelven con timestamp</a:t>
                       </a:r>
                       <a:endParaRPr lang="en-US" sz="1050" dirty="0">
                         <a:latin typeface="Calibri" charset="0"/>
@@ -23954,8 +23996,8 @@
         </p:nvSpPr>
         <p:spPr>
           <a:xfrm>
-            <a:off x="457200" y="5806440"/>
-            <a:ext cx="5212080" cy="548640"/>
+            <a:off x="457200" y="5870448"/>
+            <a:ext cx="5212080" cy="502920"/>
           </a:xfrm>
           <a:prstGeom prst="rect">
             <a:avLst/>

</xml_diff>

<commit_message>
Tercera ronda: correcciones de texto desde la trazabilidad
- P13 y notas slide 5: costo del holdout «cerca del 4 % (10,3 de 237 M)» en vez de «≤ 4 %»
- P6 y notas slide 2: no contactados «entre 29 % y 32 % en los cuatro cuartiles»
- P17 y notas slide 6: eliminada la mención al 0,67 sin gap (no reproducible desde work/output)
- Gráfico slide 3: las tres barras de AUC salen de la logística (0,820 / 0,944 / 0,997)
- Deck regenerado; qa_deck.py y validate.py en verde; sin cambios en cálculos ni salidas

Co-Authored-By: Claude Fable 5.1 <noreply@anthropic.com>
</commit_message>
<xml_diff>
--- a/entregables/BancoW_Priorizacion_Renovaciones_DavinsonArteaga.pptx
+++ b/entregables/BancoW_Priorizacion_Renovaciones_DavinsonArteaga.pptx
@@ -113,37 +113,37 @@
   <p:extLst>
     <p:ext uri="{521415D9-36F7-43E2-AB2F-B90AF26B5E84}">
       <p14:sectionLst xmlns:p14="http://schemas.microsoft.com/office/powerpoint/2010/main">
-        <p14:section name="Decisión" id="{e947533a-1f8c-ddc9-6a8d-dc7f84333afb}">
+        <p14:section name="Decisión" id="{e9f31a0d-397b-8867-dfbe-56bb269d0875}">
           <p14:sldIdLst>
             <p14:sldId id="256"/>
           </p14:sldIdLst>
         </p14:section>
-        <p14:section name="Datos" id="{e80421bd-7d7d-c0a0-8877-68a39b68fed6}">
+        <p14:section name="Datos" id="{68687150-3602-484a-0941-9f6517c1d253}">
           <p14:sldIdLst>
             <p14:sldId id="257"/>
           </p14:sldIdLst>
         </p14:section>
-        <p14:section name="Alternativas" id="{22e6a8a1-7a02-047a-9b86-4cdcce09a56a}">
+        <p14:section name="Alternativas" id="{20f0819c-1626-47d9-7c0e-a65cd6979644}">
           <p14:sldIdLst>
             <p14:sldId id="258"/>
           </p14:sldIdLst>
         </p14:section>
-        <p14:section name="Valor" id="{6d5c723c-b6d9-03f2-6343-c404c537882d}">
+        <p14:section name="Valor" id="{4fc722d8-d9e8-5379-6e30-5e0ef208b379}">
           <p14:sldIdLst>
             <p14:sldId id="259"/>
           </p14:sldIdLst>
         </p14:section>
-        <p14:section name="Piloto" id="{b121952c-9a25-e750-c985-3de904b0b9b1}">
+        <p14:section name="Piloto" id="{483e50f1-10ec-6603-5819-a22227e44ee4}">
           <p14:sldIdLst>
             <p14:sldId id="260"/>
           </p14:sldIdLst>
         </p14:section>
-        <p14:section name="Recomendación" id="{746314d4-711a-3af3-61a3-83cd38e026d5}">
+        <p14:section name="Recomendación" id="{30e5bb2a-9f5e-84bc-2889-b7d8df712cf3}">
           <p14:sldIdLst>
             <p14:sldId id="261"/>
           </p14:sldIdLst>
         </p14:section>
-        <p14:section name="Anexo" id="{b2138efb-b2ad-2767-aee6-74243d776485}">
+        <p14:section name="Anexo" id="{5675a295-83ce-ec0e-428e-910a547753e9}">
           <p14:sldIdLst>
             <p14:sldId id="262"/>
           </p14:sldIdLst>
@@ -276,10 +276,10 @@
                   <c:v>0.82</c:v>
                 </c:pt>
                 <c:pt idx="1">
-                  <c:v>0.94</c:v>
+                  <c:v>0.944</c:v>
                 </c:pt>
                 <c:pt idx="2">
-                  <c:v>1</c:v>
+                  <c:v>0.997</c:v>
                 </c:pt>
               </c:numCache>
             </c:numRef>
@@ -1206,7 +1206,7 @@
           <a:p>
             <a:r>
               <a:rPr lang="en-US" dirty="0"/>
-              <a:t>Detalle de cada hallazgo en la guía P5 y P6. Fuga: 78 % de «Acepta» renueva; dias_hasta_renovacion es nulo exactamente en los 1.436 no renovados. Calidad: max_mora_6m = −4, ahorro −350.000, contacto fechado 2026-09-15 con corte agosto; score de buró 352–912 está dentro de la escala DataCrédito 150–950 (confirmar central, versión y vigencia). contactabilidad_score no predice el contacto (32 % de no contactados en todos los cuartiles). cuotas_pagadas_pct, monto_preaprobado y dias_ultimo_contacto quedan fuera del set limpio hasta certificar su timestamp (51 contactos fechados dentro del mes de corte y 1 después): no cuesta señal (AUC univariado 0,50–0,53); en producción se recalcula a la fecha de corte. Accuracy trivial: 79,8 % en la base, 96,4 % en producción sin acertar un renovador.</a:t>
+              <a:t>Detalle de cada hallazgo en la guía P5 y P6. Fuga: 78 % de «Acepta» renueva; dias_hasta_renovacion es nulo exactamente en los 1.436 no renovados. Calidad: max_mora_6m = −4, ahorro −350.000, contacto fechado 2026-09-15 con corte agosto; score de buró 352–912 está dentro de la escala DataCrédito 150–950 (confirmar central, versión y vigencia). contactabilidad_score no predice el contacto (entre 29 % y 32 % de no contactados en los cuatro cuartiles). cuotas_pagadas_pct, monto_preaprobado y dias_ultimo_contacto quedan fuera del set limpio hasta certificar su timestamp (51 contactos fechados dentro del mes de corte y 1 después): no cuesta señal (AUC univariado 0,50–0,53); en producción se recalcula a la fecha de corte. Accuracy trivial: 79,8 % en la base, 96,4 % en producción sin acertar un renovador.</a:t>
             </a:r>
             <a:endParaRPr lang="en-US" dirty="0"/>
           </a:p>
@@ -1470,7 +1470,7 @@
           <a:p>
             <a:r>
               <a:rPr lang="en-US" dirty="0"/>
-              <a:t>Mecánica: el universo elegible del mes (filtrado por el mismo piso de riesgo: corte de buró y max_mora pactados con Riesgos) se parte al azar en dos pools por cliente, estratificando por regional y tercil de score. El champion elige sus 4.000 en su pool; el challenger rankea el suyo, toma su top 4.800, retiene 800 al azar como holdout sin contacto y contacta 4.000. Capacidad intacta: 8.000. Dos reglas separadas: calidad de lista (challenger vs. champion) y efecto del contacto (challenger contactado vs. holdout). Baseline del holdout: no el 2,3 % global, sino el orgánico del tercil alto de buró (≈ 5 %, 7 de 129, IC 2,7–10,8 %), porque el holdout sale del top de B. Potencia (800 vs. 4.000, baseline 5 %): conservador +1,7 pp exige 1.856 en holdout, 2,3 meses, 4,6 M/mes de costo; plausible +3,8 pp (el uplift implícito si B convierte 8,8 % sobre un orgánico de 5 %) exige 444, 0,6 meses, 10,3 M/mes. Dos meses detectan el escenario plausible con margen; el conservador necesita un tercer mes. El costo es ≤ 4 % del VE de B. Limitación: sin holdout en el champion no comparamos la incrementalidad de las dos políticas; la opción de 400 de holdout en el champion cuesta ≈ 2,3 M/mes y deja ese brazo en 3.600. Probar mora 5,1 % vs. 7,2 % exigiría 2.053 renovados por brazo: el riesgo entra por política y se vigila por vintage. Duración: dos meses de asignación + 30 días de ventana + 30 a 60 de maduración; decisión a los 90 días. Jerga (SRM, CSI, Brier, CUPED) en el anexo y la guía. Condiciones completas de no liberación en la guía P16.</a:t>
+              <a:t>Mecánica: el universo elegible del mes (filtrado por el mismo piso de riesgo: corte de buró y max_mora pactados con Riesgos) se parte al azar en dos pools por cliente, estratificando por regional y tercil de score. El champion elige sus 4.000 en su pool; el challenger rankea el suyo, toma su top 4.800, retiene 800 al azar como holdout sin contacto y contacta 4.000. Capacidad intacta: 8.000. Dos reglas separadas: calidad de lista (challenger vs. champion) y efecto del contacto (challenger contactado vs. holdout). Baseline del holdout: no el 2,3 % global, sino el orgánico del tercil alto de buró (≈ 5 %, 7 de 129, IC 2,7–10,8 %), porque el holdout sale del top de B. Potencia (800 vs. 4.000, baseline 5 %): conservador +1,7 pp exige 1.856 en holdout, 2,3 meses, 4,6 M/mes de costo; plausible +3,8 pp (el uplift implícito si B convierte 8,8 % sobre un orgánico de 5 %) exige 444, 0,6 meses, 10,3 M/mes. Dos meses detectan el escenario plausible con margen; el conservador necesita un tercer mes. El costo es cerca del 4 % del VE de B (10,3 de 237 M). Limitación: sin holdout en el champion no comparamos la incrementalidad de las dos políticas; la opción de 400 de holdout en el champion cuesta ≈ 2,3 M/mes y deja ese brazo en 3.600. Probar mora 5,1 % vs. 7,2 % exigiría 2.053 renovados por brazo: el riesgo entra por política y se vigila por vintage. Duración: dos meses de asignación + 30 días de ventana + 30 a 60 de maduración; decisión a los 90 días. Jerga (SRM, CSI, Brier, CUPED) en el anexo y la guía. Condiciones completas de no liberación en la guía P16.</a:t>
             </a:r>
             <a:endParaRPr lang="en-US" dirty="0"/>
           </a:p>
@@ -1558,7 +1558,7 @@
           <a:p>
             <a:r>
               <a:rPr lang="en-US" dirty="0"/>
-              <a:t>Pedimos tres decisiones. Ruta de 90 días con la ficha de fuga variable por variable para A y B en las semanas 3 a 4 (fuente, timestamp, disponibilidad al puntuar). Gobierno: sin cuotas, el modelo limpio selecciona 28 % en Oriente frente a 35 % en Centro (AIR ≈ 0,80 puntual, pero con 100 a 200 clientes por regional el intervalo bootstrap es 0,49–0,88: el 0,80 no informa y el 0,67 de la partición sin gap cae dentro; la regla está pensada para el universo mensual de 25.000, donde el intervalo se estrecha unas seis veces); con cuotas, la selección por regional la fija la capacidad, así que la equidad se vigila en conversión y calibración por grupo dentro de cada regional. El 79 % de la lista cae en el tercil alto de buró: ese piso lo fija la política de riesgo, no el algoritmo. SHAP es correlación: en la base, 37 % del tercil bajo de buró quedó sin contactar frente a 22 % del alto.</a:t>
+              <a:t>Pedimos tres decisiones. Ruta de 90 días con la ficha de fuga variable por variable para A y B en las semanas 3 a 4 (fuente, timestamp, disponibilidad al puntuar). Gobierno: sin cuotas, el modelo limpio selecciona 28 % en Oriente frente a 35 % en Centro (AIR ≈ 0,80 puntual, pero con 100 a 200 clientes por regional el intervalo bootstrap es 0,49–0,88: el 0,80 no informa; la regla está pensada para el universo mensual de 25.000, donde el intervalo se estrecha unas seis veces); con cuotas, la selección por regional la fija la capacidad, así que la equidad se vigila en conversión y calibración por grupo dentro de cada regional. El 79 % de la lista cae en el tercil alto de buró: ese piso lo fija la política de riesgo, no el algoritmo. SHAP es correlación: en la base, 37 % del tercil bajo de buró quedó sin contactar frente a 22 % del alto.</a:t>
             </a:r>
             <a:endParaRPr lang="en-US" dirty="0"/>
           </a:p>

</xml_diff>

<commit_message>
Add QA scripts for PowerPoint layout and PDF overlap checks
- Introduced `qa_layout.ps1` for validating PowerPoint presentations, ensuring a minimum margin of 15% in text boxes and checking for overlaps between text, tables, and charts.
- Added `qa_pdf.py` to analyze exported PDFs for overlapping words and content that extends beyond the page boundaries, providing feedback on font usage and page count.
</commit_message>
<xml_diff>
--- a/entregables/BancoW_Priorizacion_Renovaciones_DavinsonArteaga.pptx
+++ b/entregables/BancoW_Priorizacion_Renovaciones_DavinsonArteaga.pptx
@@ -5,7 +5,7 @@
     <p:sldMasterId id="2147483648" r:id="rId1"/>
   </p:sldMasterIdLst>
   <p:notesMasterIdLst>
-    <p:notesMasterId r:id="rId9"/>
+    <p:notesMasterId r:id="rId11"/>
   </p:notesMasterIdLst>
   <p:sldIdLst>
     <p:sldId id="256" r:id="rId2"/>
@@ -15,21 +15,23 @@
     <p:sldId id="260" r:id="rId6"/>
     <p:sldId id="261" r:id="rId7"/>
     <p:sldId id="262" r:id="rId8"/>
+    <p:sldId id="263" r:id="rId9"/>
+    <p:sldId id="264" r:id="rId10"/>
   </p:sldIdLst>
   <p:sldSz cx="12192000" cy="6858000"/>
   <p:notesSz cx="6858000" cy="12192000"/>
   <p:embeddedFontLst>
-    <p:embeddedFont>
-      <p:font typeface="Bahnschrift" panose="020B0502040204020203" pitchFamily="34" charset="0"/>
-      <p:regular r:id="rId10"/>
-      <p:bold r:id="rId11"/>
-    </p:embeddedFont>
     <p:embeddedFont>
       <p:font typeface="Segoe UI" panose="020B0502040204020203" pitchFamily="34" charset="0"/>
       <p:regular r:id="rId12"/>
       <p:bold r:id="rId13"/>
       <p:italic r:id="rId14"/>
       <p:boldItalic r:id="rId15"/>
+    </p:embeddedFont>
+    <p:embeddedFont>
+      <p:font typeface="Segoe UI Semibold" panose="020B0702040204020203" pitchFamily="34" charset="0"/>
+      <p:bold r:id="rId16"/>
+      <p:boldItalic r:id="rId17"/>
     </p:embeddedFont>
   </p:embeddedFontLst>
   <p:defaultTextStyle>
@@ -127,39 +129,49 @@
   <p:extLst>
     <p:ext uri="{521415D9-36F7-43E2-AB2F-B90AF26B5E84}">
       <p14:sectionLst xmlns:p14="http://schemas.microsoft.com/office/powerpoint/2010/main">
-        <p14:section name="Decisión" id="{68ACA854-E014-F8CF-6349-7B29E939711A}">
+        <p14:section name="Portada" id="{03A7516D-D7EF-A486-DE1D-A763170EF15B}">
           <p14:sldIdLst>
             <p14:sldId id="256"/>
           </p14:sldIdLst>
         </p14:section>
-        <p14:section name="Datos" id="{C9569D9A-E534-6037-E33A-C2DDE950FB2F}">
+        <p14:section name="Decisión" id="{FD402425-FF1B-860C-E20A-53B4E86C2FEA}">
           <p14:sldIdLst>
             <p14:sldId id="257"/>
           </p14:sldIdLst>
         </p14:section>
-        <p14:section name="Alternativas" id="{BCC98D3B-E568-BAF2-C71C-D59E5723041F}">
+        <p14:section name="Datos" id="{52A61670-1782-F338-0910-413EEC9F6DBE}">
           <p14:sldIdLst>
             <p14:sldId id="258"/>
           </p14:sldIdLst>
         </p14:section>
-        <p14:section name="Valor" id="{6A769390-7F4D-3EBA-6F4B-6E8C4A8EAA05}">
+        <p14:section name="Alternativas" id="{3A90A2A1-63A3-02E4-55D1-953A26FB89C2}">
           <p14:sldIdLst>
             <p14:sldId id="259"/>
           </p14:sldIdLst>
         </p14:section>
-        <p14:section name="Piloto" id="{C78D31A6-E73E-E3D1-A4D0-271971CEF880}">
+        <p14:section name="Valor" id="{DE4069AF-DC53-2500-E154-FE25F4A12A08}">
           <p14:sldIdLst>
             <p14:sldId id="260"/>
           </p14:sldIdLst>
         </p14:section>
-        <p14:section name="Recomendación" id="{16E00BCB-0D05-629C-C999-64B8B030D7A9}">
+        <p14:section name="Piloto" id="{1C53400F-5B07-7C41-894E-93B37568E684}">
           <p14:sldIdLst>
             <p14:sldId id="261"/>
           </p14:sldIdLst>
         </p14:section>
-        <p14:section name="Anexo" id="{D39B5254-7828-6C25-F04D-22407AEA539C}">
+        <p14:section name="Recomendación" id="{52569D96-77BB-9D4B-B0E4-79B7914BD0BB}">
           <p14:sldIdLst>
             <p14:sldId id="262"/>
+          </p14:sldIdLst>
+        </p14:section>
+        <p14:section name="Cierre" id="{52926122-3698-1256-BDA6-C43DA8028394}">
+          <p14:sldIdLst>
+            <p14:sldId id="263"/>
+          </p14:sldIdLst>
+        </p14:section>
+        <p14:section name="Anexo" id="{3D24ECE4-10FE-D7E7-B2EB-F602D2F48C6B}">
+          <p14:sldIdLst>
+            <p14:sldId id="264"/>
           </p14:sldIdLst>
         </p14:section>
       </p14:sectionLst>
@@ -212,7 +224,7 @@
             <c:bubble3D val="0"/>
             <c:extLst>
               <c:ext xmlns:c16="http://schemas.microsoft.com/office/drawing/2014/chart" uri="{C3380CC4-5D6E-409C-BE32-E72D297353CC}">
-                <c16:uniqueId val="{00000001-C14E-45CD-B3AE-5AB2D8CAD3EE}"/>
+                <c16:uniqueId val="{00000001-7BD4-4FAF-AA64-2E81D849B6D5}"/>
               </c:ext>
             </c:extLst>
           </c:dPt>
@@ -228,7 +240,7 @@
             </c:spPr>
             <c:extLst>
               <c:ext xmlns:c16="http://schemas.microsoft.com/office/drawing/2014/chart" uri="{C3380CC4-5D6E-409C-BE32-E72D297353CC}">
-                <c16:uniqueId val="{00000003-C14E-45CD-B3AE-5AB2D8CAD3EE}"/>
+                <c16:uniqueId val="{00000003-7BD4-4FAF-AA64-2E81D849B6D5}"/>
               </c:ext>
             </c:extLst>
           </c:dPt>
@@ -244,7 +256,7 @@
             </c:spPr>
             <c:extLst>
               <c:ext xmlns:c16="http://schemas.microsoft.com/office/drawing/2014/chart" uri="{C3380CC4-5D6E-409C-BE32-E72D297353CC}">
-                <c16:uniqueId val="{00000005-C14E-45CD-B3AE-5AB2D8CAD3EE}"/>
+                <c16:uniqueId val="{00000005-7BD4-4FAF-AA64-2E81D849B6D5}"/>
               </c:ext>
             </c:extLst>
           </c:dPt>
@@ -322,7 +334,7 @@
           </c:val>
           <c:extLst>
             <c:ext xmlns:c16="http://schemas.microsoft.com/office/drawing/2014/chart" uri="{C3380CC4-5D6E-409C-BE32-E72D297353CC}">
-              <c16:uniqueId val="{00000006-C14E-45CD-B3AE-5AB2D8CAD3EE}"/>
+              <c16:uniqueId val="{00000006-7BD4-4FAF-AA64-2E81D849B6D5}"/>
             </c:ext>
           </c:extLst>
         </c:ser>
@@ -463,7 +475,7 @@
             <c:bubble3D val="0"/>
             <c:extLst>
               <c:ext xmlns:c16="http://schemas.microsoft.com/office/drawing/2014/chart" uri="{C3380CC4-5D6E-409C-BE32-E72D297353CC}">
-                <c16:uniqueId val="{00000001-9582-4D68-8F7B-AB142B56DE3D}"/>
+                <c16:uniqueId val="{00000001-43A8-49AD-90FF-B110BA1E3923}"/>
               </c:ext>
             </c:extLst>
           </c:dPt>
@@ -473,7 +485,7 @@
             <c:bubble3D val="0"/>
             <c:extLst>
               <c:ext xmlns:c16="http://schemas.microsoft.com/office/drawing/2014/chart" uri="{C3380CC4-5D6E-409C-BE32-E72D297353CC}">
-                <c16:uniqueId val="{00000003-9582-4D68-8F7B-AB142B56DE3D}"/>
+                <c16:uniqueId val="{00000003-43A8-49AD-90FF-B110BA1E3923}"/>
               </c:ext>
             </c:extLst>
           </c:dPt>
@@ -489,7 +501,7 @@
             </c:spPr>
             <c:extLst>
               <c:ext xmlns:c16="http://schemas.microsoft.com/office/drawing/2014/chart" uri="{C3380CC4-5D6E-409C-BE32-E72D297353CC}">
-                <c16:uniqueId val="{00000005-9582-4D68-8F7B-AB142B56DE3D}"/>
+                <c16:uniqueId val="{00000005-43A8-49AD-90FF-B110BA1E3923}"/>
               </c:ext>
             </c:extLst>
           </c:dPt>
@@ -499,7 +511,7 @@
             <c:bubble3D val="0"/>
             <c:extLst>
               <c:ext xmlns:c16="http://schemas.microsoft.com/office/drawing/2014/chart" uri="{C3380CC4-5D6E-409C-BE32-E72D297353CC}">
-                <c16:uniqueId val="{00000007-9582-4D68-8F7B-AB142B56DE3D}"/>
+                <c16:uniqueId val="{00000007-43A8-49AD-90FF-B110BA1E3923}"/>
               </c:ext>
             </c:extLst>
           </c:dPt>
@@ -583,7 +595,7 @@
           </c:val>
           <c:extLst>
             <c:ext xmlns:c16="http://schemas.microsoft.com/office/drawing/2014/chart" uri="{C3380CC4-5D6E-409C-BE32-E72D297353CC}">
-              <c16:uniqueId val="{00000008-9582-4D68-8F7B-AB142B56DE3D}"/>
+              <c16:uniqueId val="{00000008-43A8-49AD-90FF-B110BA1E3923}"/>
             </c:ext>
           </c:extLst>
         </c:ser>
@@ -731,7 +743,7 @@
     </p:spTree>
     <p:extLst>
       <p:ext uri="{BB962C8B-B14F-4D97-AF65-F5344CB8AC3E}">
-        <p14:creationId xmlns:p14="http://schemas.microsoft.com/office/powerpoint/2010/main" val="2130559029"/>
+        <p14:creationId xmlns:p14="http://schemas.microsoft.com/office/powerpoint/2010/main" val="1412986682"/>
       </p:ext>
     </p:extLst>
   </p:cSld>
@@ -877,7 +889,7 @@
           <a:p>
             <a:r>
               <a:rPr lang="en-US" dirty="0"/>
-              <a:t>Pregunta del enunciado: ¿Qué decisión debemos tomar y por qué importa? Mensaje: la restricción es la capacidad, así que el problema es decidir a quién contactar, no predecir. KPI incremental neto de riesgo; el proxy mensual (incrementales por 1.000 contactos) sirve mientras madura la mora. 12 % sin denominador no es una meta: 960 si es sobre 8.000, 3.000 si es sobre 25.000 (37,5 % por contacto). Punto de equilibrio: una renovación deja de aportar si la mora supera 23,3 % (420.000 / 1.800.000). Guardrail de riesgo: la mora esperada de la lista (score y política de Riesgos) se verifica antes de ejecutar; el vintage de mora 30+ a 60 días por cohorte confirma (alarma y pausa). La pregunta única define si el histórico permite medir causalidad o solo describe la política vigente; hoy podemos ordenar por propensión, filtrar riesgo con la política de Riesgos y valorar cada renovación.</a:t>
+              <a:t>Portada. La presentación responde, en orden, las seis preguntas del enunciado: qué decisión tomar, qué dicen los datos, qué alternativas sobreviven, cuál genera más valor, cómo probarlo y qué hacer ahora. Duración objetivo: 15 minutos más 15 de preguntas.</a:t>
             </a:r>
           </a:p>
         </p:txBody>
@@ -964,7 +976,7 @@
           <a:p>
             <a:r>
               <a:rPr lang="en-US" dirty="0"/>
-              <a:t>Pregunta del enunciado: ¿Qué descubrimos en los datos y qué no deberíamos confiar? Detalle de cada hallazgo en la guía P5 y P6. Fuga: 78 % de «Acepta» renueva; dias_hasta_renovacion es nulo exactamente en los 1.436 no renovados. Calidad: max_mora_6m = −4, ahorro −350.000, contacto fechado 2026-09-15 con corte agosto; score de buró 352–912 está dentro de la escala DataCrédito 150–950 (confirmar central, versión y vigencia). contactabilidad_score no predice el contacto (entre 29 % y 32 % de no contactados en los cuatro cuartiles). cuotas_pagadas_pct, monto_preaprobado y dias_ultimo_contacto quedan fuera del set limpio hasta certificar su timestamp (51 contactos fechados dentro del mes de corte y 1 después): no cuesta señal (AUC univariado 0,50–0,53); en producción se recalcula a la fecha de corte. Partición rolling-origin con un corte de gap (entrenar ≤ t−2, probar en t, mayo a agosto); deduplicar por cliente. Evaluación con probabilidades calibradas. Accuracy trivial: 79,8 % en la base, 96,4 % en producción sin acertar un renovador.</a:t>
+              <a:t>Pregunta del enunciado: ¿Qué decisión debemos tomar y por qué importa? Mensaje: la restricción es la capacidad, así que el problema es decidir a quién contactar, no predecir. KPI incremental neto de riesgo; el proxy mensual (incrementales por 1.000 contactos) sirve mientras madura la mora. 12 % sin denominador no es una meta: 960 si es sobre 8.000, 3.000 si es sobre 25.000 (37,5 % por contacto). Punto de equilibrio: una renovación deja de aportar si la mora supera 23,3 % (420.000 / 1.800.000). Guardrail de riesgo: la mora esperada de la lista (score y política de Riesgos) se verifica antes de ejecutar; el vintage de mora 30+ a 60 días por cohorte confirma (alarma y pausa). La pregunta única define si el histórico permite medir causalidad o solo describe la política vigente; hoy podemos ordenar por propensión, filtrar riesgo con la política de Riesgos y valorar cada renovación.</a:t>
             </a:r>
           </a:p>
         </p:txBody>
@@ -1051,7 +1063,7 @@
           <a:p>
             <a:r>
               <a:rPr lang="en-US" dirty="0"/>
-              <a:t>Pregunta del enunciado: ¿Qué alternativas de modelo tenemos y cuáles sobreviven al análisis? Repliqué con la base: el AUC de C (0,94) solo se obtiene incluyendo el resultado de gestión; con dias_hasta_renovacion llega a 1,00. Validación temporal: entrenar ≤ t−2, probar en t, mayo a agosto; k-fold aleatorio da 0,82 y no revela la fuga. A: 0,86 supera lo que esta base permite replicar (0,82), pero la hoja viene de otra población, así que no es concluyente; su mora 7,2 % es la peor y, de ser real, lo convierte en la alternativa de menor valor; ambas cosas exigen auditoría variable por variable. B: coherente con la réplica, calibrado (pendiente 0,91), estable; pasa a piloto tras la misma ficha de fuga. D: la hoja reporta «+3,1 pp incremental» en la columna de mora y Qini en la de PR-AUC; no es comparable con A, B y C sin aclarar unidades. Las conversiones «top 8k» de la hoja y la conversión top 32 % de la réplica (≈ 45 %) no son comparables: otra población y otra regla de contacto. Para comparar propensión vs. uplift: la regla de asignación de la campaña de D (fracción aleatorizada, unidad, cumplimiento) y un mismo holdout donde medir uplift@8k de cada modelo en COP netos de mora, con intervalos.</a:t>
+              <a:t>Pregunta del enunciado: ¿Qué descubrimos en los datos y qué no deberíamos confiar? Detalle de cada hallazgo en la guía P5 y P6. Fuga: 78 % de «Acepta» renueva; dias_hasta_renovacion es nulo exactamente en los 1.436 no renovados. Calidad: max_mora_6m = −4, ahorro −350.000, contacto fechado 2026-09-15 con corte agosto; score de buró 352–912 está dentro de la escala DataCrédito 150–950 (confirmar central, versión y vigencia). contactabilidad_score no predice el contacto (entre 29 % y 32 % de no contactados en los cuatro cuartiles). cuotas_pagadas_pct, monto_preaprobado y dias_ultimo_contacto quedan fuera del set limpio hasta certificar su timestamp (51 contactos fechados dentro del mes de corte y 1 después): no cuesta señal (AUC univariado 0,50–0,53); en producción se recalcula a la fecha de corte. Partición rolling-origin con un corte de gap (entrenar ≤ t−2, probar en t, mayo a agosto); deduplicar por cliente. Evaluación con probabilidades calibradas. Accuracy trivial: 79,8 % en la base, 96,4 % en producción sin acertar un renovador.</a:t>
             </a:r>
           </a:p>
         </p:txBody>
@@ -1138,7 +1150,7 @@
           <a:p>
             <a:r>
               <a:rPr lang="en-US" dirty="0"/>
-              <a:t>Pregunta del enunciado: ¿Cuál genera mayor valor bajo riesgo y capacidad real? B gana por riesgo, no por conversión: 237 M netos al mes frente a 218 M de A; cada renovación de B vale 337.200 frente a 290.400 de A. Incertidumbre (supuesto 8.000 contactos por alternativa, 752 y 704 renovados): conversión z = 1,32 (p 0,19), mora z = 2,11 (p 0,03); en valor B es al menos equivalente dentro de la incertidumbre. El valor no es incremental: el orgánico del tercil alto de buró (de donde sale el top de B) es ≈ 5 % (7 de 129 no contactados renovaron solos; IC 2,7–10,8 %), así que ≈ 57 % de las renovaciones de B serían orgánicas y el valor incremental ≈ 103 M (129 M con orgánico 4 %, 76 M con 6 %). Por eso el piloto. Faltan el costo de contacto, la LGD real y el origen del «top 8k». Capacidad: un ranking global sobrecarga Centro, Norte y Eje y deja ≈ 400 cupos ociosos en Suroccidente y Oriente; cuotas por regional con transferencia por valor marginal (tope a pactar con Comercial, 10 % como referencia). Proyección a centenas con la mezcla regional de la muestra de test. La conversión en muestra con y sin cuotas es equivalente (41,9 % vs. 43,5 %, cuatro renovaciones de diferencia, dentro del ruido). Sensibilidad a la pérdida por mora de 1,0 / 1,8 / 2,5 / 3,5 M: B 263 / 237 / 215 / 182 vs. A 262 / 218 / 181 / 126.</a:t>
+              <a:t>Pregunta del enunciado: ¿Qué alternativas de modelo tenemos y cuáles sobreviven al análisis? Repliqué con la base: el AUC de C (0,94) solo se obtiene incluyendo el resultado de gestión; con dias_hasta_renovacion llega a 0,997 con la misma logística (1,00 redondeado). Validación temporal: entrenar ≤ t−2, probar en t, mayo a agosto; k-fold aleatorio da 0,82 y no revela la fuga. A: 0,86 supera lo que esta base permite replicar (0,82), pero la hoja viene de otra población, así que no es concluyente; su mora 7,2 % es la peor y, de ser real, lo convierte en la alternativa de menor valor; ambas cosas exigen auditoría variable por variable. B: coherente con la réplica, calibrado (pendiente 0,91), estable; pasa a piloto tras la misma ficha de fuga. D: la hoja reporta «+3,1 pp incremental» en la columna de mora y Qini en la de PR-AUC; no es comparable con A, B y C sin aclarar unidades. Las conversiones «top 8k» de la hoja y la conversión top 32 % de la réplica (≈ 45 %) no son comparables: otra población y otra regla de contacto. Para comparar propensión vs. uplift: la regla de asignación de la campaña de D (fracción aleatorizada, unidad, cumplimiento) y un mismo holdout donde medir uplift@8k de cada modelo en COP netos de mora, con intervalos.</a:t>
             </a:r>
           </a:p>
         </p:txBody>
@@ -1225,7 +1237,7 @@
           <a:p>
             <a:r>
               <a:rPr lang="en-US" dirty="0"/>
-              <a:t>Pregunta del enunciado: ¿Cómo probaríamos que funciona y cómo controlamos el riesgo? Mecánica: el universo elegible del mes (filtrado por el mismo piso de riesgo: corte de buró y max_mora pactados con Riesgos) se parte al azar en dos pools por cliente, estratificando por regional y tercil de score. El champion elige sus 4.000 en su pool; el challenger rankea el suyo con cuotas por regional, toma su top 4.800, retiene 800 al azar como holdout sin contacto y contacta 4.000. Capacidad intacta: 8.000. Dos reglas separadas: calidad de lista (challenger vs. champion) y efecto del contacto (challenger contactado vs. holdout). Calidad: 3,6 % a 5,4 % se detecta con 2.081 por brazo, es decir en un mes con 4.000. Baseline del holdout: no el 2,3 % global, sino el orgánico del tercil alto de buró (≈ 5 %, 7 de 129, IC 2,7–10,8 %), porque el holdout sale del top de B. Potencia (800 vs. 4.000, baseline 5 %): conservador +1,7 pp exige 1.856 en holdout, 2,3 meses, 4,6 M/mes de costo; plausible +3,8 pp (el uplift implícito si B convierte 8,8 % sobre un orgánico de 5 %) exige 444, 0,6 meses, 10,3 M/mes. Dos meses detectan el escenario plausible con margen; el conservador necesita un tercer mes. El costo es cerca del 4 % del VE de B (10,3 de 237 M). Limitación: sin holdout en el champion no comparamos la incrementalidad de las dos políticas; la opción de 400 de holdout en el champion cuesta ≈ 2,3 M/mes y deja ese brazo en 3.600. Probar mora 5,1 % vs. 7,2 % exigiría 2.053 renovados por brazo: el riesgo entra por política y se vigila por vintage. Reglas de salida pre-registradas: calidad ≥ +1,5 pp con IC 95 % que excluye 0; efecto &gt; 0 con IC 95 % que excluye 0; mora ≤ champion + 1 pp. Duración: dos meses de asignación + 30 días de ventana + 30 a 60 de maduración; decisión a los 90 días. Jerga (SRM, CSI, Brier, CUPED) en el anexo y la guía. Condiciones completas de no liberación en la guía P16.</a:t>
+              <a:t>Pregunta del enunciado: ¿Cuál genera mayor valor bajo riesgo y capacidad real? B gana por riesgo, no por conversión: 237 M netos al mes frente a 218 M de A; cada renovación de B vale 337.200 frente a 290.400 de A. Incertidumbre (supuesto 8.000 contactos por alternativa, 752 y 704 renovados): conversión z = 1,32 (p 0,19), mora z = 2,11 (p 0,03); en valor B es al menos equivalente dentro de la incertidumbre. El valor no es incremental: el orgánico del tercil alto de buró (de donde sale el top de B) es ≈ 5 % (7 de 129 no contactados renovaron solos; IC 2,7–10,8 %), así que ≈ 57 % de las renovaciones de B serían orgánicas y el valor incremental ≈ 103 M (129 M con orgánico 4 %, 76 M con 6 %). Por eso el piloto. Faltan el costo de contacto, la LGD real y el origen del «top 8k». Capacidad: un ranking global sobrecarga Centro, Norte y Eje y deja ≈ 400 cupos ociosos en Suroccidente y Oriente; cuotas por regional con transferencia por valor marginal (tope a pactar con Comercial, 10 % como referencia). Proyección a centenas con la mezcla regional de la muestra de test. La conversión en muestra con y sin cuotas es equivalente (41,9 % vs. 43,5 %, cuatro renovaciones de diferencia, dentro del ruido). Sensibilidad a la pérdida por mora de 1,0 / 1,8 / 2,5 / 3,5 M: B 263 / 237 / 215 / 182 vs. A 262 / 218 / 181 / 126.</a:t>
             </a:r>
           </a:p>
         </p:txBody>
@@ -1312,7 +1324,7 @@
           <a:p>
             <a:r>
               <a:rPr lang="en-US" dirty="0"/>
-              <a:t>Pregunta del enunciado: ¿Qué recomienda hacer ahora? Pedimos tres decisiones; A queda condicionada a la verificación de sus variables y D a los datos del piloto. Ruta de 90 días con la ficha de fuga variable por variable para A y B en las semanas 3 a 4 (fuente, timestamp, disponibilidad al puntuar); pipeline point-in-time. Gobierno: sin cuotas, el modelo limpio selecciona 28 % en Oriente frente a 35 % en Centro (AIR ≈ 0,80 puntual, pero con 100 a 200 clientes por regional el intervalo bootstrap es 0,49–0,88: el 0,80 no informa; la regla está pensada para el universo mensual de 25.000, donde el intervalo se estrecha unas seis veces); con cuotas, la selección por regional la fija la capacidad, así que la equidad se vigila en conversión y calibración por grupo dentro de cada regional. El 79 % de la lista cae en el tercil alto de buró: ese piso lo fija la política de riesgo, no el algoritmo. Auditable: model card, datasheet, ficha de fuga, plan de monitoreo, RACI. SHAP es correlación: en la base, 37 % del tercil bajo de buró quedó sin contactar frente a 22 % del alto; solo el holdout prueba causalidad.</a:t>
+              <a:t>Pregunta del enunciado: ¿Cómo probaríamos que funciona y cómo controlamos el riesgo? Mecánica: el universo elegible del mes (filtrado por el mismo piso de riesgo: corte de buró y max_mora pactados con Riesgos) se parte al azar en dos pools por cliente, estratificando por regional y tercil de score. El champion elige sus 4.000 en su pool; el challenger rankea el suyo con cuotas por regional, toma su top 4.800, retiene 800 al azar como holdout sin contacto y contacta 4.000. Capacidad intacta: 8.000. Dos reglas separadas: calidad de lista (challenger vs. champion) y efecto del contacto (challenger contactado vs. holdout). Calidad: 3,6 % a 5,4 % se detecta con 2.081 por brazo, es decir en un mes con 4.000. Baseline del holdout: no el 2,3 % global, sino el orgánico del tercil alto de buró (≈ 5 %, 7 de 129, IC 2,7–10,8 %), porque el holdout sale del top de B. Potencia (800 vs. 4.000, baseline 5 %): conservador +1,7 pp exige 1.856 en holdout, 2,3 meses, 4,6 M/mes de costo; plausible +3,8 pp (el uplift implícito si B convierte 8,8 % sobre un orgánico de 5 %) exige 444, 0,6 meses, 10,3 M/mes. Dos meses detectan el escenario plausible con margen; el conservador necesita un tercer mes. El costo es cerca del 4 % del VE de B (10,3 de 237 M). Limitación: sin holdout en el champion no comparamos la incrementalidad de las dos políticas; la opción de 400 de holdout en el champion cuesta ≈ 2,3 M/mes y deja ese brazo en 3.600. Probar mora 5,1 % vs. 7,2 % exigiría 2.053 renovados por brazo: el riesgo entra por política y se vigila por vintage. Reglas de salida pre-registradas: calidad ≥ +1,5 pp con IC 95 % que excluye 0; efecto &gt; 0 con IC 95 % que excluye 0; mora ≤ champion + 1 pp. Duración: dos meses de asignación + 30 días de ventana + 30 a 60 de maduración; decisión a los 90 días. Jerga (SRM, CSI, Brier, CUPED) en el anexo y la guía. Condiciones completas de no liberación en la guía P16.</a:t>
             </a:r>
           </a:p>
         </p:txBody>
@@ -1399,6 +1411,180 @@
           <a:p>
             <a:r>
               <a:rPr lang="en-US" dirty="0"/>
+              <a:t>Pregunta del enunciado: ¿Qué recomienda hacer ahora? Pedimos tres decisiones; A queda condicionada a la verificación de sus variables y D a los datos del piloto. Ruta de 90 días con la ficha de fuga variable por variable para A y B en las semanas 3 a 4 (fuente, timestamp, disponibilidad al puntuar); pipeline point-in-time. Gobierno: sin cuotas, el modelo limpio selecciona 28 % en Oriente frente a 35 % en Centro (AIR ≈ 0,80 puntual, pero con 100 a 200 clientes por regional el intervalo bootstrap es 0,49–0,88: el 0,80 no informa; la regla está pensada para el universo mensual de 25.000, donde el intervalo se estrecha unas seis veces); con cuotas, la selección por regional la fija la capacidad, así que la equidad se vigila en conversión y calibración por grupo dentro de cada regional. El 79 % de la lista cae en el tercil alto de buró: ese piso lo fija la política de riesgo, no el algoritmo. Auditable: model card, datasheet, ficha de fuga, plan de monitoreo, RACI. SHAP es correlación: en la base, 37 % del tercil bajo de buró quedó sin contactar frente a 22 % del alto; solo el holdout prueba causalidad.</a:t>
+            </a:r>
+          </a:p>
+        </p:txBody>
+      </p:sp>
+      <p:sp>
+        <p:nvSpPr>
+          <p:cNvPr id="4" name="Slide Number Placeholder 3"/>
+          <p:cNvSpPr>
+            <a:spLocks noGrp="1"/>
+          </p:cNvSpPr>
+          <p:nvPr>
+            <p:ph type="sldNum" sz="quarter" idx="10"/>
+          </p:nvPr>
+        </p:nvSpPr>
+        <p:spPr/>
+        <p:txBody>
+          <a:bodyPr/>
+          <a:lstStyle/>
+          <a:p>
+            <a:fld id="{F7021451-1387-4CA6-816F-3879F97B5CBC}" type="slidenum">
+              <a:rPr lang="en-US"/>
+              <a:t>7</a:t>
+            </a:fld>
+            <a:endParaRPr lang="en-US"/>
+          </a:p>
+        </p:txBody>
+      </p:sp>
+    </p:spTree>
+    <p:extLst>
+      <p:ext uri="{BB962C8B-B14F-4D97-AF65-F5344CB8AC3E}">
+        <p14:creationId xmlns:p14="http://schemas.microsoft.com/office/powerpoint/2010/main" val="1024086991"/>
+      </p:ext>
+    </p:extLst>
+  </p:cSld>
+  <p:clrMapOvr>
+    <a:masterClrMapping/>
+  </p:clrMapOvr>
+</p:notes>
+</file>
+
+<file path=ppt/notesSlides/notesSlide8.xml><?xml version="1.0" encoding="utf-8"?>
+<p:notes xmlns:a="http://schemas.openxmlformats.org/drawingml/2006/main" xmlns:r="http://schemas.openxmlformats.org/officeDocument/2006/relationships" xmlns:p="http://schemas.openxmlformats.org/presentationml/2006/main">
+  <p:cSld>
+    <p:spTree>
+      <p:nvGrpSpPr>
+        <p:cNvPr id="1" name=""/>
+        <p:cNvGrpSpPr/>
+        <p:nvPr/>
+      </p:nvGrpSpPr>
+      <p:grpSpPr>
+        <a:xfrm>
+          <a:off x="0" y="0"/>
+          <a:ext cx="0" cy="0"/>
+          <a:chOff x="0" y="0"/>
+          <a:chExt cx="0" cy="0"/>
+        </a:xfrm>
+      </p:grpSpPr>
+      <p:sp>
+        <p:nvSpPr>
+          <p:cNvPr id="2" name="Slide Image Placeholder 1"/>
+          <p:cNvSpPr>
+            <a:spLocks noGrp="1" noRot="1" noChangeAspect="1"/>
+          </p:cNvSpPr>
+          <p:nvPr>
+            <p:ph type="sldImg"/>
+          </p:nvPr>
+        </p:nvSpPr>
+        <p:spPr/>
+      </p:sp>
+      <p:sp>
+        <p:nvSpPr>
+          <p:cNvPr id="3" name="Notes Placeholder 2"/>
+          <p:cNvSpPr>
+            <a:spLocks noGrp="1"/>
+          </p:cNvSpPr>
+          <p:nvPr>
+            <p:ph type="body" idx="1"/>
+          </p:nvPr>
+        </p:nvSpPr>
+        <p:spPr/>
+        <p:txBody>
+          <a:bodyPr/>
+          <a:lstStyle/>
+          <a:p>
+            <a:r>
+              <a:rPr lang="en-US" dirty="0"/>
+              <a:t>Cierre: repetir las tres decisiones y abrir preguntas. Si preguntan por detalle técnico, ir al anexo (réplica fuera de tiempo, valor esperado, tamaños de muestra, variables excluidas) o a la guía de 19 preguntas.</a:t>
+            </a:r>
+          </a:p>
+        </p:txBody>
+      </p:sp>
+      <p:sp>
+        <p:nvSpPr>
+          <p:cNvPr id="4" name="Slide Number Placeholder 3"/>
+          <p:cNvSpPr>
+            <a:spLocks noGrp="1"/>
+          </p:cNvSpPr>
+          <p:nvPr>
+            <p:ph type="sldNum" sz="quarter" idx="10"/>
+          </p:nvPr>
+        </p:nvSpPr>
+        <p:spPr/>
+        <p:txBody>
+          <a:bodyPr/>
+          <a:lstStyle/>
+          <a:p>
+            <a:fld id="{F7021451-1387-4CA6-816F-3879F97B5CBC}" type="slidenum">
+              <a:rPr lang="en-US"/>
+              <a:t>8</a:t>
+            </a:fld>
+            <a:endParaRPr lang="en-US"/>
+          </a:p>
+        </p:txBody>
+      </p:sp>
+    </p:spTree>
+    <p:extLst>
+      <p:ext uri="{BB962C8B-B14F-4D97-AF65-F5344CB8AC3E}">
+        <p14:creationId xmlns:p14="http://schemas.microsoft.com/office/powerpoint/2010/main" val="1024086991"/>
+      </p:ext>
+    </p:extLst>
+  </p:cSld>
+  <p:clrMapOvr>
+    <a:masterClrMapping/>
+  </p:clrMapOvr>
+</p:notes>
+</file>
+
+<file path=ppt/notesSlides/notesSlide9.xml><?xml version="1.0" encoding="utf-8"?>
+<p:notes xmlns:a="http://schemas.openxmlformats.org/drawingml/2006/main" xmlns:r="http://schemas.openxmlformats.org/officeDocument/2006/relationships" xmlns:p="http://schemas.openxmlformats.org/presentationml/2006/main">
+  <p:cSld>
+    <p:spTree>
+      <p:nvGrpSpPr>
+        <p:cNvPr id="1" name=""/>
+        <p:cNvGrpSpPr/>
+        <p:nvPr/>
+      </p:nvGrpSpPr>
+      <p:grpSpPr>
+        <a:xfrm>
+          <a:off x="0" y="0"/>
+          <a:ext cx="0" cy="0"/>
+          <a:chOff x="0" y="0"/>
+          <a:chExt cx="0" cy="0"/>
+        </a:xfrm>
+      </p:grpSpPr>
+      <p:sp>
+        <p:nvSpPr>
+          <p:cNvPr id="2" name="Slide Image Placeholder 1"/>
+          <p:cNvSpPr>
+            <a:spLocks noGrp="1" noRot="1" noChangeAspect="1"/>
+          </p:cNvSpPr>
+          <p:nvPr>
+            <p:ph type="sldImg"/>
+          </p:nvPr>
+        </p:nvSpPr>
+        <p:spPr/>
+      </p:sp>
+      <p:sp>
+        <p:nvSpPr>
+          <p:cNvPr id="3" name="Notes Placeholder 2"/>
+          <p:cNvSpPr>
+            <a:spLocks noGrp="1"/>
+          </p:cNvSpPr>
+          <p:nvPr>
+            <p:ph type="body" idx="1"/>
+          </p:nvPr>
+        </p:nvSpPr>
+        <p:spPr/>
+        <p:txBody>
+          <a:bodyPr/>
+          <a:lstStyle/>
+          <a:p>
+            <a:r>
+              <a:rPr lang="en-US" dirty="0"/>
               <a:t>Anexo de soporte para preguntas técnicas. Detalle completo en la guía de sustentación (19 preguntas).</a:t>
             </a:r>
           </a:p>
@@ -1421,7 +1607,7 @@
           <a:p>
             <a:fld id="{F7021451-1387-4CA6-816F-3879F97B5CBC}" type="slidenum">
               <a:rPr lang="en-US"/>
-              <a:t>7</a:t>
+              <a:t>9</a:t>
             </a:fld>
             <a:endParaRPr lang="en-US"/>
           </a:p>
@@ -1495,39 +1681,15 @@
           <a:chExt cx="0" cy="0"/>
         </a:xfrm>
       </p:grpSpPr>
-      <p:pic>
-        <p:nvPicPr>
-          <p:cNvPr id="2" name="Image 0" descr="Banco W"/>
-          <p:cNvPicPr>
-            <a:picLocks noChangeAspect="1"/>
-          </p:cNvPicPr>
-          <p:nvPr/>
-        </p:nvPicPr>
-        <p:blipFill>
-          <a:blip r:embed="rId2"/>
-          <a:stretch>
-            <a:fillRect/>
-          </a:stretch>
-        </p:blipFill>
-        <p:spPr>
-          <a:xfrm>
-            <a:off x="457200" y="6437376"/>
-            <a:ext cx="266456" cy="283464"/>
-          </a:xfrm>
-          <a:prstGeom prst="rect">
-            <a:avLst/>
-          </a:prstGeom>
-        </p:spPr>
-      </p:pic>
       <p:sp>
         <p:nvSpPr>
-          <p:cNvPr id="3" name="Text 0"/>
+          <p:cNvPr id="2" name="Text 0"/>
           <p:cNvSpPr/>
           <p:nvPr/>
         </p:nvSpPr>
         <p:spPr>
           <a:xfrm>
-            <a:off x="841248" y="6473952"/>
+            <a:off x="457200" y="6473952"/>
             <a:ext cx="7315200" cy="228600"/>
           </a:xfrm>
           <a:prstGeom prst="rect">
@@ -1552,7 +1714,7 @@
                 <a:ea typeface="Segoe UI" pitchFamily="34" charset="-122"/>
                 <a:cs typeface="Segoe UI" pitchFamily="34" charset="-120"/>
               </a:rPr>
-              <a:t>Prueba técnica Científico de Datos · Davinson Arteaga</a:t>
+              <a:t>Preparado para Banco W · Prueba técnica Científico de Datos · Davinson Arteaga</a:t>
             </a:r>
             <a:endParaRPr lang="en-US" sz="900" dirty="0"/>
           </a:p>
@@ -1560,18 +1722,18 @@
       </p:sp>
       <p:sp>
         <p:nvSpPr>
-          <p:cNvPr id="4" name="Text 1"/>
+          <p:cNvPr id="3" name="Text 1"/>
           <p:cNvSpPr>
             <a:spLocks noGrp="1"/>
           </p:cNvSpPr>
           <p:nvPr>
-            <p:ph type="title" idx="102" hasCustomPrompt="1"/>
+            <p:ph type="title" idx="101" hasCustomPrompt="1"/>
           </p:nvPr>
         </p:nvSpPr>
         <p:spPr>
           <a:xfrm>
-            <a:off x="457200" y="347472"/>
-            <a:ext cx="11277295" cy="438912"/>
+            <a:off x="457200" y="310896"/>
+            <a:ext cx="11277295" cy="512064"/>
           </a:xfrm>
           <a:prstGeom prst="rect">
             <a:avLst/>
@@ -1588,9 +1750,9 @@
                 <a:solidFill>
                   <a:srgbClr val="2E2E2E"/>
                 </a:solidFill>
-                <a:latin typeface="Bahnschrift" pitchFamily="34" charset="0"/>
-                <a:ea typeface="Bahnschrift" pitchFamily="34" charset="-122"/>
-                <a:cs typeface="Bahnschrift" pitchFamily="34" charset="-120"/>
+                <a:latin typeface="Segoe UI Semibold" pitchFamily="34" charset="0"/>
+                <a:ea typeface="Segoe UI Semibold" pitchFamily="34" charset="-122"/>
+                <a:cs typeface="Segoe UI Semibold" pitchFamily="34" charset="-120"/>
               </a:defRPr>
             </a:lvl1pPr>
           </a:lstStyle>
@@ -1614,8 +1776,8 @@
         </p:nvSpPr>
         <p:spPr>
           <a:xfrm>
-            <a:off x="11274552" y="6473952"/>
-            <a:ext cx="457200" cy="228600"/>
+            <a:off x="11274552" y="6419088"/>
+            <a:ext cx="457200" cy="347472"/>
           </a:xfrm>
           <a:prstGeom prst="rect">
             <a:avLst/>
@@ -1658,6 +1820,39 @@
 </p:sldLayout>
 </file>
 
+<file path=ppt/slideLayouts/slideLayout3.xml><?xml version="1.0" encoding="utf-8"?>
+<p:sldLayout xmlns:a="http://schemas.openxmlformats.org/drawingml/2006/main" xmlns:r="http://schemas.openxmlformats.org/officeDocument/2006/relationships" xmlns:p="http://schemas.openxmlformats.org/presentationml/2006/main" preserve="1">
+  <p:cSld name="HERO">
+    <p:bg>
+      <p:bgPr>
+        <a:solidFill>
+          <a:srgbClr val="005C63"/>
+        </a:solidFill>
+        <a:effectLst/>
+      </p:bgPr>
+    </p:bg>
+    <p:spTree>
+      <p:nvGrpSpPr>
+        <p:cNvPr id="1" name=""/>
+        <p:cNvGrpSpPr/>
+        <p:nvPr/>
+      </p:nvGrpSpPr>
+      <p:grpSpPr>
+        <a:xfrm>
+          <a:off x="0" y="0"/>
+          <a:ext cx="0" cy="0"/>
+          <a:chOff x="0" y="0"/>
+          <a:chExt cx="0" cy="0"/>
+        </a:xfrm>
+      </p:grpSpPr>
+    </p:spTree>
+  </p:cSld>
+  <p:clrMapOvr>
+    <a:masterClrMapping/>
+  </p:clrMapOvr>
+</p:sldLayout>
+</file>
+
 <file path=ppt/slideMasters/slideMaster1.xml><?xml version="1.0" encoding="utf-8"?>
 <p:sldMaster xmlns:a="http://schemas.openxmlformats.org/drawingml/2006/main" xmlns:r="http://schemas.openxmlformats.org/officeDocument/2006/relationships" xmlns:p="http://schemas.openxmlformats.org/presentationml/2006/main">
   <p:cSld>
@@ -1692,8 +1887,8 @@
         </p:nvSpPr>
         <p:spPr>
           <a:xfrm>
-            <a:off x="11274552" y="6473952"/>
-            <a:ext cx="457200" cy="228600"/>
+            <a:off x="11274552" y="6419088"/>
+            <a:ext cx="457200" cy="347472"/>
           </a:xfrm>
           <a:prstGeom prst="rect">
             <a:avLst/>
@@ -1734,6 +1929,7 @@
   <p:sldLayoutIdLst>
     <p:sldLayoutId id="2147483649" r:id="rId1"/>
     <p:sldLayoutId id="2147483650" r:id="rId2"/>
+    <p:sldLayoutId id="2147483651" r:id="rId3"/>
   </p:sldLayoutIdLst>
   <p:hf sldNum="0" hdr="0" ftr="0" dt="0"/>
   <p:txStyles>
@@ -2008,18 +2204,229 @@
       </p:grpSpPr>
       <p:sp>
         <p:nvSpPr>
+          <p:cNvPr id="2" name="Shape 0"/>
+          <p:cNvSpPr/>
+          <p:nvPr/>
+        </p:nvSpPr>
+        <p:spPr>
+          <a:xfrm>
+            <a:off x="1412199" y="1600200"/>
+            <a:ext cx="914400" cy="73152"/>
+          </a:xfrm>
+          <a:prstGeom prst="rect">
+            <a:avLst/>
+          </a:prstGeom>
+          <a:solidFill>
+            <a:srgbClr val="FE6A00"/>
+          </a:solidFill>
+          <a:ln/>
+        </p:spPr>
+      </p:sp>
+      <p:sp>
+        <p:nvSpPr>
+          <p:cNvPr id="3" name="Text 1"/>
+          <p:cNvSpPr txBox="1"/>
+          <p:nvPr/>
+        </p:nvSpPr>
+        <p:spPr>
+          <a:xfrm>
+            <a:off x="1412199" y="1828800"/>
+            <a:ext cx="8412114" cy="1417320"/>
+          </a:xfrm>
+          <a:prstGeom prst="rect">
+            <a:avLst/>
+          </a:prstGeom>
+          <a:noFill/>
+          <a:ln/>
+        </p:spPr>
+        <p:txBody>
+          <a:bodyPr wrap="square" lIns="0" tIns="0" rIns="0" bIns="0" rtlCol="0" anchor="t"/>
+          <a:lstStyle/>
+          <a:p>
+            <a:pPr marL="0" indent="0">
+              <a:lnSpc>
+                <a:spcPct val="100000"/>
+              </a:lnSpc>
+              <a:buNone/>
+            </a:pPr>
+            <a:r>
+              <a:rPr lang="en-US" sz="4000" dirty="0">
+                <a:solidFill>
+                  <a:srgbClr val="FFFFFF"/>
+                </a:solidFill>
+                <a:latin typeface="Segoe UI Semibold" pitchFamily="34" charset="0"/>
+                <a:ea typeface="Segoe UI Semibold" pitchFamily="34" charset="-122"/>
+                <a:cs typeface="Segoe UI Semibold" pitchFamily="34" charset="-120"/>
+              </a:rPr>
+              <a:t>Priorizar renovaciones con capacidad limitada</a:t>
+            </a:r>
+            <a:endParaRPr lang="en-US" sz="4000" dirty="0"/>
+          </a:p>
+        </p:txBody>
+      </p:sp>
+      <p:sp>
+        <p:nvSpPr>
+          <p:cNvPr id="4" name="Text 2"/>
+          <p:cNvSpPr txBox="1"/>
+          <p:nvPr/>
+        </p:nvSpPr>
+        <p:spPr>
+          <a:xfrm>
+            <a:off x="1412199" y="3383280"/>
+            <a:ext cx="9367114" cy="457200"/>
+          </a:xfrm>
+          <a:prstGeom prst="rect">
+            <a:avLst/>
+          </a:prstGeom>
+          <a:noFill/>
+          <a:ln/>
+        </p:spPr>
+        <p:txBody>
+          <a:bodyPr wrap="square" lIns="0" tIns="0" rIns="0" bIns="0" rtlCol="0" anchor="t"/>
+          <a:lstStyle/>
+          <a:p>
+            <a:pPr marL="0" indent="0">
+              <a:lnSpc>
+                <a:spcPct val="115000"/>
+              </a:lnSpc>
+              <a:buNone/>
+            </a:pPr>
+            <a:r>
+              <a:rPr lang="en-US" sz="2000" dirty="0">
+                <a:solidFill>
+                  <a:srgbClr val="FFFFFF"/>
+                </a:solidFill>
+                <a:latin typeface="Segoe UI" pitchFamily="34" charset="0"/>
+                <a:ea typeface="Segoe UI" pitchFamily="34" charset="-122"/>
+                <a:cs typeface="Segoe UI" pitchFamily="34" charset="-120"/>
+              </a:rPr>
+              <a:t>A quién contactar cada mes con 8.000 cupos, netos de riesgo</a:t>
+            </a:r>
+            <a:endParaRPr lang="en-US" sz="2000" dirty="0"/>
+          </a:p>
+        </p:txBody>
+      </p:sp>
+      <p:sp>
+        <p:nvSpPr>
+          <p:cNvPr id="5" name="Text 3"/>
+          <p:cNvSpPr txBox="1"/>
+          <p:nvPr/>
+        </p:nvSpPr>
+        <p:spPr>
+          <a:xfrm>
+            <a:off x="1412199" y="4572000"/>
+            <a:ext cx="9367114" cy="1097280"/>
+          </a:xfrm>
+          <a:prstGeom prst="rect">
+            <a:avLst/>
+          </a:prstGeom>
+          <a:noFill/>
+          <a:ln/>
+        </p:spPr>
+        <p:txBody>
+          <a:bodyPr wrap="square" lIns="0" tIns="0" rIns="0" bIns="0" rtlCol="0" anchor="t"/>
+          <a:lstStyle/>
+          <a:p>
+            <a:pPr marL="0" indent="0">
+              <a:lnSpc>
+                <a:spcPct val="115000"/>
+              </a:lnSpc>
+              <a:buNone/>
+            </a:pPr>
+            <a:r>
+              <a:rPr lang="en-US" sz="1400" b="1" dirty="0">
+                <a:solidFill>
+                  <a:srgbClr val="FFFFFF"/>
+                </a:solidFill>
+                <a:latin typeface="Segoe UI" pitchFamily="34" charset="0"/>
+                <a:ea typeface="Segoe UI" pitchFamily="34" charset="-122"/>
+                <a:cs typeface="Segoe UI" pitchFamily="34" charset="-120"/>
+              </a:rPr>
+              <a:t>Davinson Arteaga</a:t>
+            </a:r>
+            <a:endParaRPr lang="en-US" sz="1400" dirty="0"/>
+          </a:p>
+          <a:p>
+            <a:pPr marL="0" indent="0">
+              <a:lnSpc>
+                <a:spcPct val="115000"/>
+              </a:lnSpc>
+              <a:buNone/>
+            </a:pPr>
+            <a:r>
+              <a:rPr lang="en-US" sz="1400" dirty="0">
+                <a:solidFill>
+                  <a:srgbClr val="FFFFFF"/>
+                </a:solidFill>
+                <a:latin typeface="Segoe UI" pitchFamily="34" charset="0"/>
+                <a:ea typeface="Segoe UI" pitchFamily="34" charset="-122"/>
+                <a:cs typeface="Segoe UI" pitchFamily="34" charset="-120"/>
+              </a:rPr>
+              <a:t>Prueba técnica · Científico de Datos</a:t>
+            </a:r>
+            <a:endParaRPr lang="en-US" sz="1400" dirty="0"/>
+          </a:p>
+          <a:p>
+            <a:pPr marL="0" indent="0">
+              <a:lnSpc>
+                <a:spcPct val="115000"/>
+              </a:lnSpc>
+              <a:buNone/>
+            </a:pPr>
+            <a:r>
+              <a:rPr lang="en-US" sz="1400" dirty="0">
+                <a:solidFill>
+                  <a:srgbClr val="FFFFFF"/>
+                </a:solidFill>
+                <a:latin typeface="Segoe UI" pitchFamily="34" charset="0"/>
+                <a:ea typeface="Segoe UI" pitchFamily="34" charset="-122"/>
+                <a:cs typeface="Segoe UI" pitchFamily="34" charset="-120"/>
+              </a:rPr>
+              <a:t>Preparado para Banco W · Octubre de 2026</a:t>
+            </a:r>
+            <a:endParaRPr lang="en-US" sz="1400" dirty="0"/>
+          </a:p>
+        </p:txBody>
+      </p:sp>
+    </p:spTree>
+  </p:cSld>
+  <p:clrMapOvr>
+    <a:masterClrMapping/>
+  </p:clrMapOvr>
+</p:sld>
+</file>
+
+<file path=ppt/slides/slide2.xml><?xml version="1.0" encoding="utf-8"?>
+<p:sld xmlns:a="http://schemas.openxmlformats.org/drawingml/2006/main" xmlns:r="http://schemas.openxmlformats.org/officeDocument/2006/relationships" xmlns:p="http://schemas.openxmlformats.org/presentationml/2006/main">
+  <p:cSld name="Slide 2">
+    <p:spTree>
+      <p:nvGrpSpPr>
+        <p:cNvPr id="1" name=""/>
+        <p:cNvGrpSpPr/>
+        <p:nvPr/>
+      </p:nvGrpSpPr>
+      <p:grpSpPr>
+        <a:xfrm>
+          <a:off x="0" y="0"/>
+          <a:ext cx="0" cy="0"/>
+          <a:chOff x="0" y="0"/>
+          <a:chExt cx="0" cy="0"/>
+        </a:xfrm>
+      </p:grpSpPr>
+      <p:sp>
+        <p:nvSpPr>
           <p:cNvPr id="2" name="Text 1"/>
           <p:cNvSpPr>
             <a:spLocks noGrp="1"/>
           </p:cNvSpPr>
           <p:nvPr>
-            <p:ph type="title" idx="102" hasCustomPrompt="1"/>
+            <p:ph type="title" idx="101" hasCustomPrompt="1"/>
           </p:nvPr>
         </p:nvSpPr>
         <p:spPr>
           <a:xfrm>
-            <a:off x="457200" y="347472"/>
-            <a:ext cx="11277295" cy="438912"/>
+            <a:off x="457200" y="310896"/>
+            <a:ext cx="11277295" cy="512064"/>
           </a:xfrm>
           <a:prstGeom prst="rect">
             <a:avLst/>
@@ -2039,9 +2446,9 @@
                 <a:solidFill>
                   <a:srgbClr val="2E2E2E"/>
                 </a:solidFill>
-                <a:latin typeface="Bahnschrift" pitchFamily="34" charset="0"/>
-                <a:ea typeface="Bahnschrift" pitchFamily="34" charset="-122"/>
-                <a:cs typeface="Bahnschrift" pitchFamily="34" charset="-120"/>
+                <a:latin typeface="Segoe UI Semibold" pitchFamily="34" charset="0"/>
+                <a:ea typeface="Segoe UI Semibold" pitchFamily="34" charset="-122"/>
+                <a:cs typeface="Segoe UI Semibold" pitchFamily="34" charset="-120"/>
               </a:rPr>
               <a:t>Contactar a los 8.000 que más valor dejan, netos de riesgo</a:t>
             </a:r>
@@ -2139,17 +2546,17 @@
               <a:buNone/>
             </a:pPr>
             <a:r>
-              <a:rPr lang="en-US" sz="3200" dirty="0">
+              <a:rPr lang="en-US" sz="2800" dirty="0">
                 <a:solidFill>
                   <a:srgbClr val="E35A00"/>
                 </a:solidFill>
-                <a:latin typeface="Bahnschrift" pitchFamily="34" charset="0"/>
-                <a:ea typeface="Bahnschrift" pitchFamily="34" charset="-122"/>
-                <a:cs typeface="Bahnschrift" pitchFamily="34" charset="-120"/>
+                <a:latin typeface="Segoe UI Semibold" pitchFamily="34" charset="0"/>
+                <a:ea typeface="Segoe UI Semibold" pitchFamily="34" charset="-122"/>
+                <a:cs typeface="Segoe UI Semibold" pitchFamily="34" charset="-120"/>
               </a:rPr>
               <a:t>8.000 de 25.000</a:t>
             </a:r>
-            <a:endParaRPr lang="en-US" sz="3200" dirty="0"/>
+            <a:endParaRPr lang="en-US" sz="2800" dirty="0"/>
           </a:p>
         </p:txBody>
       </p:sp>
@@ -2162,7 +2569,7 @@
         <p:spPr>
           <a:xfrm>
             <a:off x="457200" y="2377440"/>
-            <a:ext cx="3637117" cy="548640"/>
+            <a:ext cx="3637117" cy="603504"/>
           </a:xfrm>
           <a:prstGeom prst="rect">
             <a:avLst/>
@@ -2223,17 +2630,17 @@
               <a:buNone/>
             </a:pPr>
             <a:r>
-              <a:rPr lang="en-US" sz="3200" dirty="0">
+              <a:rPr lang="en-US" sz="2800" dirty="0">
                 <a:solidFill>
                   <a:srgbClr val="E35A00"/>
                 </a:solidFill>
-                <a:latin typeface="Bahnschrift" pitchFamily="34" charset="0"/>
-                <a:ea typeface="Bahnschrift" pitchFamily="34" charset="-122"/>
-                <a:cs typeface="Bahnschrift" pitchFamily="34" charset="-120"/>
+                <a:latin typeface="Segoe UI Semibold" pitchFamily="34" charset="0"/>
+                <a:ea typeface="Segoe UI Semibold" pitchFamily="34" charset="-122"/>
+                <a:cs typeface="Segoe UI Semibold" pitchFamily="34" charset="-120"/>
               </a:rPr>
               <a:t>3,6 % = 288</a:t>
             </a:r>
-            <a:endParaRPr lang="en-US" sz="3200" dirty="0"/>
+            <a:endParaRPr lang="en-US" sz="2800" dirty="0"/>
           </a:p>
         </p:txBody>
       </p:sp>
@@ -2246,7 +2653,7 @@
         <p:spPr>
           <a:xfrm>
             <a:off x="4277197" y="2377440"/>
-            <a:ext cx="3637117" cy="548640"/>
+            <a:ext cx="3637117" cy="603504"/>
           </a:xfrm>
           <a:prstGeom prst="rect">
             <a:avLst/>
@@ -2307,17 +2714,17 @@
               <a:buNone/>
             </a:pPr>
             <a:r>
-              <a:rPr lang="en-US" sz="3200" dirty="0">
+              <a:rPr lang="en-US" sz="2800" dirty="0">
                 <a:solidFill>
                   <a:srgbClr val="E35A00"/>
                 </a:solidFill>
-                <a:latin typeface="Bahnschrift" pitchFamily="34" charset="0"/>
-                <a:ea typeface="Bahnschrift" pitchFamily="34" charset="-122"/>
-                <a:cs typeface="Bahnschrift" pitchFamily="34" charset="-120"/>
+                <a:latin typeface="Segoe UI Semibold" pitchFamily="34" charset="0"/>
+                <a:ea typeface="Segoe UI Semibold" pitchFamily="34" charset="-122"/>
+                <a:cs typeface="Segoe UI Semibold" pitchFamily="34" charset="-120"/>
               </a:rPr>
               <a:t>1 mora = 4,3 sanas</a:t>
             </a:r>
-            <a:endParaRPr lang="en-US" sz="3200" dirty="0"/>
+            <a:endParaRPr lang="en-US" sz="2800" dirty="0"/>
           </a:p>
         </p:txBody>
       </p:sp>
@@ -2330,7 +2737,7 @@
         <p:spPr>
           <a:xfrm>
             <a:off x="8097195" y="2377440"/>
-            <a:ext cx="3637117" cy="548640"/>
+            <a:ext cx="3637117" cy="603504"/>
           </a:xfrm>
           <a:prstGeom prst="rect">
             <a:avLst/>
@@ -2395,7 +2802,7 @@
         <p:spPr>
           <a:xfrm>
             <a:off x="457200" y="3246120"/>
-            <a:ext cx="4592117" cy="256032"/>
+            <a:ext cx="4592117" cy="292608"/>
           </a:xfrm>
           <a:prstGeom prst="rect">
             <a:avLst/>
@@ -2531,7 +2938,7 @@
         <p:spPr>
           <a:xfrm>
             <a:off x="457200" y="5138928"/>
-            <a:ext cx="4592117" cy="256032"/>
+            <a:ext cx="4592117" cy="292608"/>
           </a:xfrm>
           <a:prstGeom prst="rect">
             <a:avLst/>
@@ -2615,7 +3022,7 @@
         <p:spPr>
           <a:xfrm>
             <a:off x="5232197" y="3246120"/>
-            <a:ext cx="6502116" cy="256032"/>
+            <a:ext cx="6502116" cy="292608"/>
           </a:xfrm>
           <a:prstGeom prst="rect">
             <a:avLst/>
@@ -3687,8 +4094,8 @@
         </p:nvSpPr>
         <p:spPr>
           <a:xfrm>
-            <a:off x="11274552" y="6473952"/>
-            <a:ext cx="457200" cy="228600"/>
+            <a:off x="11274552" y="6419088"/>
+            <a:ext cx="457200" cy="347472"/>
           </a:xfrm>
           <a:prstGeom prst="rect">
             <a:avLst/>
@@ -3717,7 +4124,7 @@
             <a:pPr algn="r"/>
             <a:fld id="{F7021451-1387-4CA6-816F-3879F97B5CBC}" type="slidenum">
               <a:rPr lang="en-US" b="0"/>
-              <a:t>1</a:t>
+              <a:t>2</a:t>
             </a:fld>
             <a:endParaRPr lang="en-US"/>
           </a:p>
@@ -3731,9 +4138,9 @@
 </p:sld>
 </file>
 
-<file path=ppt/slides/slide2.xml><?xml version="1.0" encoding="utf-8"?>
+<file path=ppt/slides/slide3.xml><?xml version="1.0" encoding="utf-8"?>
 <p:sld xmlns:a="http://schemas.openxmlformats.org/drawingml/2006/main" xmlns:r="http://schemas.openxmlformats.org/officeDocument/2006/relationships" xmlns:p="http://schemas.openxmlformats.org/presentationml/2006/main">
-  <p:cSld name="Slide 2">
+  <p:cSld name="Slide 3">
     <p:spTree>
       <p:nvGrpSpPr>
         <p:cNvPr id="1" name=""/>
@@ -3755,13 +4162,13 @@
             <a:spLocks noGrp="1"/>
           </p:cNvSpPr>
           <p:nvPr>
-            <p:ph type="title" idx="102" hasCustomPrompt="1"/>
+            <p:ph type="title" idx="101" hasCustomPrompt="1"/>
           </p:nvPr>
         </p:nvSpPr>
         <p:spPr>
           <a:xfrm>
-            <a:off x="457200" y="347472"/>
-            <a:ext cx="11277295" cy="438912"/>
+            <a:off x="457200" y="310896"/>
+            <a:ext cx="11277295" cy="512064"/>
           </a:xfrm>
           <a:prstGeom prst="rect">
             <a:avLst/>
@@ -3781,9 +4188,9 @@
                 <a:solidFill>
                   <a:srgbClr val="2E2E2E"/>
                 </a:solidFill>
-                <a:latin typeface="Bahnschrift" pitchFamily="34" charset="0"/>
-                <a:ea typeface="Bahnschrift" pitchFamily="34" charset="-122"/>
-                <a:cs typeface="Bahnschrift" pitchFamily="34" charset="-120"/>
+                <a:latin typeface="Segoe UI Semibold" pitchFamily="34" charset="0"/>
+                <a:ea typeface="Segoe UI Semibold" pitchFamily="34" charset="-122"/>
+                <a:cs typeface="Segoe UI Semibold" pitchFamily="34" charset="-120"/>
               </a:rPr>
               <a:t>Los datos sirven para ordenar clientes, no para medir riesgo ni efecto</a:t>
             </a:r>
@@ -3862,7 +4269,7 @@
         <p:spPr>
           <a:xfrm>
             <a:off x="457200" y="1828800"/>
-            <a:ext cx="11277295" cy="256032"/>
+            <a:ext cx="11277295" cy="292608"/>
           </a:xfrm>
           <a:prstGeom prst="rect">
             <a:avLst/>
@@ -5305,7 +5712,7 @@
         <p:spPr>
           <a:xfrm>
             <a:off x="457200" y="4617720"/>
-            <a:ext cx="11277295" cy="256032"/>
+            <a:ext cx="11277295" cy="292608"/>
           </a:xfrm>
           <a:prstGeom prst="rect">
             <a:avLst/>
@@ -5477,8 +5884,8 @@
         </p:nvSpPr>
         <p:spPr>
           <a:xfrm>
-            <a:off x="11274552" y="6473952"/>
-            <a:ext cx="457200" cy="228600"/>
+            <a:off x="11274552" y="6419088"/>
+            <a:ext cx="457200" cy="347472"/>
           </a:xfrm>
           <a:prstGeom prst="rect">
             <a:avLst/>
@@ -5507,7 +5914,7 @@
             <a:pPr algn="r"/>
             <a:fld id="{F7021451-1387-4CA6-816F-3879F97B5CBC}" type="slidenum">
               <a:rPr lang="en-US" b="0"/>
-              <a:t>2</a:t>
+              <a:t>3</a:t>
             </a:fld>
             <a:endParaRPr lang="en-US"/>
           </a:p>
@@ -5521,9 +5928,9 @@
 </p:sld>
 </file>
 
-<file path=ppt/slides/slide3.xml><?xml version="1.0" encoding="utf-8"?>
+<file path=ppt/slides/slide4.xml><?xml version="1.0" encoding="utf-8"?>
 <p:sld xmlns:a="http://schemas.openxmlformats.org/drawingml/2006/main" xmlns:r="http://schemas.openxmlformats.org/officeDocument/2006/relationships" xmlns:p="http://schemas.openxmlformats.org/presentationml/2006/main">
-  <p:cSld name="Slide 3">
+  <p:cSld name="Slide 4">
     <p:spTree>
       <p:nvGrpSpPr>
         <p:cNvPr id="1" name=""/>
@@ -5545,13 +5952,13 @@
             <a:spLocks noGrp="1"/>
           </p:cNvSpPr>
           <p:nvPr>
-            <p:ph type="title" idx="102" hasCustomPrompt="1"/>
+            <p:ph type="title" idx="101" hasCustomPrompt="1"/>
           </p:nvPr>
         </p:nvSpPr>
         <p:spPr>
           <a:xfrm>
-            <a:off x="457200" y="347472"/>
-            <a:ext cx="11277295" cy="438912"/>
+            <a:off x="457200" y="310896"/>
+            <a:ext cx="11277295" cy="512064"/>
           </a:xfrm>
           <a:prstGeom prst="rect">
             <a:avLst/>
@@ -5571,9 +5978,9 @@
                 <a:solidFill>
                   <a:srgbClr val="2E2E2E"/>
                 </a:solidFill>
-                <a:latin typeface="Bahnschrift" pitchFamily="34" charset="0"/>
-                <a:ea typeface="Bahnschrift" pitchFamily="34" charset="-122"/>
-                <a:cs typeface="Bahnschrift" pitchFamily="34" charset="-120"/>
+                <a:latin typeface="Segoe UI Semibold" pitchFamily="34" charset="0"/>
+                <a:ea typeface="Segoe UI Semibold" pitchFamily="34" charset="-122"/>
+                <a:cs typeface="Segoe UI Semibold" pitchFamily="34" charset="-120"/>
               </a:rPr>
               <a:t>B pasa a piloto, A se verifica antes y C se descarta</a:t>
             </a:r>
@@ -5716,7 +6123,7 @@
                   </a:extLst>
                 </a:gridCol>
               </a:tblGrid>
-              <a:tr h="384048">
+              <a:tr h="274320">
                 <a:tc>
                   <a:txBody>
                     <a:bodyPr/>
@@ -5875,7 +6282,7 @@
                           <a:ea typeface="Segoe UI" pitchFamily="34" charset="-122"/>
                           <a:cs typeface="Segoe UI" pitchFamily="34" charset="-120"/>
                         </a:rPr>
-                        <a:t>Conversión reportada</a:t>
+                        <a:t>Conversión</a:t>
                       </a:r>
                       <a:endParaRPr lang="en-US" sz="1050" dirty="0">
                         <a:latin typeface="Segoe UI" charset="0"/>
@@ -8010,7 +8417,7 @@
         <p:spPr>
           <a:xfrm>
             <a:off x="8097195" y="1828800"/>
-            <a:ext cx="3637117" cy="256032"/>
+            <a:ext cx="3637117" cy="292608"/>
           </a:xfrm>
           <a:prstGeom prst="rect">
             <a:avLst/>
@@ -8052,7 +8459,7 @@
         <p:spPr>
           <a:xfrm>
             <a:off x="8097195" y="2121408"/>
-            <a:ext cx="3637117" cy="411480"/>
+            <a:ext cx="3637117" cy="502920"/>
           </a:xfrm>
           <a:prstGeom prst="rect">
             <a:avLst/>
@@ -8109,8 +8516,8 @@
         </p:nvSpPr>
         <p:spPr>
           <a:xfrm>
-            <a:off x="8097195" y="4279392"/>
-            <a:ext cx="3637117" cy="411480"/>
+            <a:off x="8097195" y="4261104"/>
+            <a:ext cx="3637117" cy="530352"/>
           </a:xfrm>
           <a:prstGeom prst="rect">
             <a:avLst/>
@@ -8175,7 +8582,7 @@
         <p:spPr>
           <a:xfrm>
             <a:off x="457200" y="5074920"/>
-            <a:ext cx="5547116" cy="256032"/>
+            <a:ext cx="5547116" cy="292608"/>
           </a:xfrm>
           <a:prstGeom prst="rect">
             <a:avLst/>
@@ -8287,7 +8694,7 @@
         <p:spPr>
           <a:xfrm>
             <a:off x="6187196" y="5074920"/>
-            <a:ext cx="5547116" cy="256032"/>
+            <a:ext cx="5547116" cy="292608"/>
           </a:xfrm>
           <a:prstGeom prst="rect">
             <a:avLst/>
@@ -8402,8 +8809,8 @@
         </p:nvSpPr>
         <p:spPr>
           <a:xfrm>
-            <a:off x="11274552" y="6473952"/>
-            <a:ext cx="457200" cy="228600"/>
+            <a:off x="11274552" y="6419088"/>
+            <a:ext cx="457200" cy="347472"/>
           </a:xfrm>
           <a:prstGeom prst="rect">
             <a:avLst/>
@@ -8432,7 +8839,7 @@
             <a:pPr algn="r"/>
             <a:fld id="{F7021451-1387-4CA6-816F-3879F97B5CBC}" type="slidenum">
               <a:rPr lang="en-US" b="0"/>
-              <a:t>3</a:t>
+              <a:t>4</a:t>
             </a:fld>
             <a:endParaRPr lang="en-US"/>
           </a:p>
@@ -8446,9 +8853,9 @@
 </p:sld>
 </file>
 
-<file path=ppt/slides/slide4.xml><?xml version="1.0" encoding="utf-8"?>
+<file path=ppt/slides/slide5.xml><?xml version="1.0" encoding="utf-8"?>
 <p:sld xmlns:a="http://schemas.openxmlformats.org/drawingml/2006/main" xmlns:r="http://schemas.openxmlformats.org/officeDocument/2006/relationships" xmlns:p="http://schemas.openxmlformats.org/presentationml/2006/main">
-  <p:cSld name="Slide 4">
+  <p:cSld name="Slide 5">
     <p:spTree>
       <p:nvGrpSpPr>
         <p:cNvPr id="1" name=""/>
@@ -8470,13 +8877,13 @@
             <a:spLocks noGrp="1"/>
           </p:cNvSpPr>
           <p:nvPr>
-            <p:ph type="title" idx="102" hasCustomPrompt="1"/>
+            <p:ph type="title" idx="101" hasCustomPrompt="1"/>
           </p:nvPr>
         </p:nvSpPr>
         <p:spPr>
           <a:xfrm>
-            <a:off x="457200" y="347472"/>
-            <a:ext cx="11277295" cy="438912"/>
+            <a:off x="457200" y="310896"/>
+            <a:ext cx="11277295" cy="512064"/>
           </a:xfrm>
           <a:prstGeom prst="rect">
             <a:avLst/>
@@ -8496,9 +8903,9 @@
                 <a:solidFill>
                   <a:srgbClr val="2E2E2E"/>
                 </a:solidFill>
-                <a:latin typeface="Bahnschrift" pitchFamily="34" charset="0"/>
-                <a:ea typeface="Bahnschrift" pitchFamily="34" charset="-122"/>
-                <a:cs typeface="Bahnschrift" pitchFamily="34" charset="-120"/>
+                <a:latin typeface="Segoe UI Semibold" pitchFamily="34" charset="0"/>
+                <a:ea typeface="Segoe UI Semibold" pitchFamily="34" charset="-122"/>
+                <a:cs typeface="Segoe UI Semibold" pitchFamily="34" charset="-120"/>
               </a:rPr>
               <a:t>B deja más valor que A: 237 frente a 218 millones al mes</a:t>
             </a:r>
@@ -8577,7 +8984,7 @@
         <p:spPr>
           <a:xfrm>
             <a:off x="457200" y="1828800"/>
-            <a:ext cx="4592117" cy="256032"/>
+            <a:ext cx="4592117" cy="292608"/>
           </a:xfrm>
           <a:prstGeom prst="rect">
             <a:avLst/>
@@ -8604,7 +9011,7 @@
                 <a:ea typeface="Segoe UI" pitchFamily="34" charset="-122"/>
                 <a:cs typeface="Segoe UI" pitchFamily="34" charset="-120"/>
               </a:rPr>
-              <a:t>Valor esperado mensual neto de mora (COP millones)</a:t>
+              <a:t>Valor esperado neto de mora, COP millones al mes</a:t>
             </a:r>
             <a:endParaRPr lang="en-US" sz="1200" dirty="0"/>
           </a:p>
@@ -8618,8 +9025,8 @@
         </p:nvSpPr>
         <p:spPr>
           <a:xfrm>
-            <a:off x="457200" y="2103120"/>
-            <a:ext cx="4592117" cy="411480"/>
+            <a:off x="457200" y="2139696"/>
+            <a:ext cx="4592117" cy="502920"/>
           </a:xfrm>
           <a:prstGeom prst="rect">
             <a:avLst/>
@@ -8659,8 +9066,8 @@
           <p:nvPr/>
         </p:nvGraphicFramePr>
         <p:xfrm>
-          <a:off x="384048" y="2606040"/>
-          <a:ext cx="4665269" cy="1737360"/>
+          <a:off x="384048" y="2670048"/>
+          <a:ext cx="4665269" cy="1673352"/>
         </p:xfrm>
         <a:graphic>
           <a:graphicData uri="http://schemas.openxmlformats.org/drawingml/2006/chart">
@@ -8696,17 +9103,17 @@
               <a:buNone/>
             </a:pPr>
             <a:r>
-              <a:rPr lang="en-US" sz="3200" dirty="0">
+              <a:rPr lang="en-US" sz="2800" dirty="0">
                 <a:solidFill>
                   <a:srgbClr val="E35A00"/>
                 </a:solidFill>
-                <a:latin typeface="Bahnschrift" pitchFamily="34" charset="0"/>
-                <a:ea typeface="Bahnschrift" pitchFamily="34" charset="-122"/>
-                <a:cs typeface="Bahnschrift" pitchFamily="34" charset="-120"/>
+                <a:latin typeface="Segoe UI Semibold" pitchFamily="34" charset="0"/>
+                <a:ea typeface="Segoe UI Semibold" pitchFamily="34" charset="-122"/>
+                <a:cs typeface="Segoe UI Semibold" pitchFamily="34" charset="-120"/>
               </a:rPr>
               <a:t>+143 M</a:t>
             </a:r>
-            <a:endParaRPr lang="en-US" sz="3200" dirty="0"/>
+            <a:endParaRPr lang="en-US" sz="2800" dirty="0"/>
           </a:p>
         </p:txBody>
       </p:sp>
@@ -8719,7 +9126,7 @@
         <p:spPr>
           <a:xfrm>
             <a:off x="5232197" y="2377440"/>
-            <a:ext cx="2682118" cy="548640"/>
+            <a:ext cx="2682118" cy="603504"/>
           </a:xfrm>
           <a:prstGeom prst="rect">
             <a:avLst/>
@@ -8780,17 +9187,17 @@
               <a:buNone/>
             </a:pPr>
             <a:r>
-              <a:rPr lang="en-US" sz="3200" dirty="0">
+              <a:rPr lang="en-US" sz="2800" dirty="0">
                 <a:solidFill>
                   <a:srgbClr val="E35A00"/>
                 </a:solidFill>
-                <a:latin typeface="Bahnschrift" pitchFamily="34" charset="0"/>
-                <a:ea typeface="Bahnschrift" pitchFamily="34" charset="-122"/>
-                <a:cs typeface="Bahnschrift" pitchFamily="34" charset="-120"/>
+                <a:latin typeface="Segoe UI Semibold" pitchFamily="34" charset="0"/>
+                <a:ea typeface="Segoe UI Semibold" pitchFamily="34" charset="-122"/>
+                <a:cs typeface="Segoe UI Semibold" pitchFamily="34" charset="-120"/>
               </a:rPr>
               <a:t>≈ 103 M</a:t>
             </a:r>
-            <a:endParaRPr lang="en-US" sz="3200" dirty="0"/>
+            <a:endParaRPr lang="en-US" sz="2800" dirty="0"/>
           </a:p>
         </p:txBody>
       </p:sp>
@@ -8803,7 +9210,7 @@
         <p:spPr>
           <a:xfrm>
             <a:off x="8097195" y="2377440"/>
-            <a:ext cx="3637117" cy="548640"/>
+            <a:ext cx="3637117" cy="603504"/>
           </a:xfrm>
           <a:prstGeom prst="rect">
             <a:avLst/>
@@ -8844,8 +9251,8 @@
         </p:nvSpPr>
         <p:spPr>
           <a:xfrm>
-            <a:off x="5232197" y="3017520"/>
-            <a:ext cx="6502116" cy="256032"/>
+            <a:off x="5232197" y="3072384"/>
+            <a:ext cx="6502116" cy="292608"/>
           </a:xfrm>
           <a:prstGeom prst="rect">
             <a:avLst/>
@@ -8886,8 +9293,8 @@
         </p:nvSpPr>
         <p:spPr>
           <a:xfrm>
-            <a:off x="5232197" y="3310128"/>
-            <a:ext cx="6502116" cy="1005840"/>
+            <a:off x="5232197" y="3383280"/>
+            <a:ext cx="6502116" cy="987552"/>
           </a:xfrm>
           <a:prstGeom prst="rect">
             <a:avLst/>
@@ -8956,8 +9363,8 @@
         </p:nvSpPr>
         <p:spPr>
           <a:xfrm>
-            <a:off x="457200" y="4480560"/>
-            <a:ext cx="11277295" cy="256032"/>
+            <a:off x="457200" y="4443984"/>
+            <a:ext cx="11277295" cy="292608"/>
           </a:xfrm>
           <a:prstGeom prst="rect">
             <a:avLst/>
@@ -9005,7 +9412,7 @@
           </p:nvPr>
         </p:nvGraphicFramePr>
         <p:xfrm>
-          <a:off x="457200" y="4773168"/>
+          <a:off x="457200" y="4754880"/>
           <a:ext cx="11277295" cy="914400"/>
         </p:xfrm>
         <a:graphic>
@@ -9056,7 +9463,7 @@
                   </a:extLst>
                 </a:gridCol>
               </a:tblGrid>
-              <a:tr h="196596">
+              <a:tr h="237744">
                 <a:tc>
                   <a:txBody>
                     <a:bodyPr/>
@@ -11015,8 +11422,8 @@
         </p:nvSpPr>
         <p:spPr>
           <a:xfrm>
-            <a:off x="457200" y="6089904"/>
-            <a:ext cx="11277295" cy="228600"/>
+            <a:off x="457200" y="6108192"/>
+            <a:ext cx="11277295" cy="274320"/>
           </a:xfrm>
           <a:prstGeom prst="rect">
             <a:avLst/>
@@ -11061,8 +11468,8 @@
         </p:nvSpPr>
         <p:spPr>
           <a:xfrm>
-            <a:off x="11274552" y="6473952"/>
-            <a:ext cx="457200" cy="228600"/>
+            <a:off x="11274552" y="6419088"/>
+            <a:ext cx="457200" cy="347472"/>
           </a:xfrm>
           <a:prstGeom prst="rect">
             <a:avLst/>
@@ -11091,7 +11498,7 @@
             <a:pPr algn="r"/>
             <a:fld id="{F7021451-1387-4CA6-816F-3879F97B5CBC}" type="slidenum">
               <a:rPr lang="en-US" b="0"/>
-              <a:t>4</a:t>
+              <a:t>5</a:t>
             </a:fld>
             <a:endParaRPr lang="en-US"/>
           </a:p>
@@ -11105,9 +11512,9 @@
 </p:sld>
 </file>
 
-<file path=ppt/slides/slide5.xml><?xml version="1.0" encoding="utf-8"?>
+<file path=ppt/slides/slide6.xml><?xml version="1.0" encoding="utf-8"?>
 <p:sld xmlns:a="http://schemas.openxmlformats.org/drawingml/2006/main" xmlns:r="http://schemas.openxmlformats.org/officeDocument/2006/relationships" xmlns:p="http://schemas.openxmlformats.org/presentationml/2006/main">
-  <p:cSld name="Slide 5">
+  <p:cSld name="Slide 6">
     <p:spTree>
       <p:nvGrpSpPr>
         <p:cNvPr id="1" name=""/>
@@ -11129,13 +11536,13 @@
             <a:spLocks noGrp="1"/>
           </p:cNvSpPr>
           <p:nvPr>
-            <p:ph type="title" idx="102" hasCustomPrompt="1"/>
+            <p:ph type="title" idx="101" hasCustomPrompt="1"/>
           </p:nvPr>
         </p:nvSpPr>
         <p:spPr>
           <a:xfrm>
-            <a:off x="457200" y="347472"/>
-            <a:ext cx="11277295" cy="438912"/>
+            <a:off x="457200" y="310896"/>
+            <a:ext cx="11277295" cy="512064"/>
           </a:xfrm>
           <a:prstGeom prst="rect">
             <a:avLst/>
@@ -11155,9 +11562,9 @@
                 <a:solidFill>
                   <a:srgbClr val="2E2E2E"/>
                 </a:solidFill>
-                <a:latin typeface="Bahnschrift" pitchFamily="34" charset="0"/>
-                <a:ea typeface="Bahnschrift" pitchFamily="34" charset="-122"/>
-                <a:cs typeface="Bahnschrift" pitchFamily="34" charset="-120"/>
+                <a:latin typeface="Segoe UI Semibold" pitchFamily="34" charset="0"/>
+                <a:ea typeface="Segoe UI Semibold" pitchFamily="34" charset="-122"/>
+                <a:cs typeface="Segoe UI Semibold" pitchFamily="34" charset="-120"/>
               </a:rPr>
               <a:t>Un piloto de dos meses mide si llamar crea renovaciones</a:t>
             </a:r>
@@ -11236,7 +11643,7 @@
         <p:spPr>
           <a:xfrm>
             <a:off x="457200" y="1828800"/>
-            <a:ext cx="6502116" cy="256032"/>
+            <a:ext cx="6502116" cy="292608"/>
           </a:xfrm>
           <a:prstGeom prst="rect">
             <a:avLst/>
@@ -11596,7 +12003,7 @@
         <p:spPr>
           <a:xfrm>
             <a:off x="457200" y="3931920"/>
-            <a:ext cx="6502116" cy="256032"/>
+            <a:ext cx="6502116" cy="292608"/>
           </a:xfrm>
           <a:prstGeom prst="rect">
             <a:avLst/>
@@ -12831,7 +13238,7 @@
         <p:spPr>
           <a:xfrm>
             <a:off x="7325076" y="1828800"/>
-            <a:ext cx="4409420" cy="256032"/>
+            <a:ext cx="4409420" cy="292608"/>
           </a:xfrm>
           <a:prstGeom prst="rect">
             <a:avLst/>
@@ -13581,7 +13988,7 @@
         <p:spPr>
           <a:xfrm>
             <a:off x="7325076" y="4480560"/>
-            <a:ext cx="4409420" cy="256032"/>
+            <a:ext cx="4409420" cy="292608"/>
           </a:xfrm>
           <a:prstGeom prst="rect">
             <a:avLst/>
@@ -13744,8 +14151,8 @@
         </p:nvSpPr>
         <p:spPr>
           <a:xfrm>
-            <a:off x="11274552" y="6473952"/>
-            <a:ext cx="457200" cy="228600"/>
+            <a:off x="11274552" y="6419088"/>
+            <a:ext cx="457200" cy="347472"/>
           </a:xfrm>
           <a:prstGeom prst="rect">
             <a:avLst/>
@@ -13774,7 +14181,7 @@
             <a:pPr algn="r"/>
             <a:fld id="{F7021451-1387-4CA6-816F-3879F97B5CBC}" type="slidenum">
               <a:rPr lang="en-US" b="0"/>
-              <a:t>5</a:t>
+              <a:t>6</a:t>
             </a:fld>
             <a:endParaRPr lang="en-US"/>
           </a:p>
@@ -13788,9 +14195,9 @@
 </p:sld>
 </file>
 
-<file path=ppt/slides/slide6.xml><?xml version="1.0" encoding="utf-8"?>
+<file path=ppt/slides/slide7.xml><?xml version="1.0" encoding="utf-8"?>
 <p:sld xmlns:a="http://schemas.openxmlformats.org/drawingml/2006/main" xmlns:r="http://schemas.openxmlformats.org/officeDocument/2006/relationships" xmlns:p="http://schemas.openxmlformats.org/presentationml/2006/main">
-  <p:cSld name="Slide 6">
+  <p:cSld name="Slide 7">
     <p:spTree>
       <p:nvGrpSpPr>
         <p:cNvPr id="1" name=""/>
@@ -13812,13 +14219,13 @@
             <a:spLocks noGrp="1"/>
           </p:cNvSpPr>
           <p:nvPr>
-            <p:ph type="title" idx="102" hasCustomPrompt="1"/>
+            <p:ph type="title" idx="101" hasCustomPrompt="1"/>
           </p:nvPr>
         </p:nvSpPr>
         <p:spPr>
           <a:xfrm>
-            <a:off x="457200" y="347472"/>
-            <a:ext cx="11277295" cy="438912"/>
+            <a:off x="457200" y="310896"/>
+            <a:ext cx="11277295" cy="512064"/>
           </a:xfrm>
           <a:prstGeom prst="rect">
             <a:avLst/>
@@ -13838,9 +14245,9 @@
                 <a:solidFill>
                   <a:srgbClr val="2E2E2E"/>
                 </a:solidFill>
-                <a:latin typeface="Bahnschrift" pitchFamily="34" charset="0"/>
-                <a:ea typeface="Bahnschrift" pitchFamily="34" charset="-122"/>
-                <a:cs typeface="Bahnschrift" pitchFamily="34" charset="-120"/>
+                <a:latin typeface="Segoe UI Semibold" pitchFamily="34" charset="0"/>
+                <a:ea typeface="Segoe UI Semibold" pitchFamily="34" charset="-122"/>
+                <a:cs typeface="Segoe UI Semibold" pitchFamily="34" charset="-120"/>
               </a:rPr>
               <a:t>Aprobar hoy el piloto de B y no liberar C</a:t>
             </a:r>
@@ -13904,7 +14311,7 @@
                 <a:ea typeface="Segoe UI" pitchFamily="34" charset="-122"/>
                 <a:cs typeface="Segoe UI" pitchFamily="34" charset="-120"/>
               </a:rPr>
-              <a:t>Pedimos tres decisiones hoy: aprobar desde el próximo corte el piloto de B con grupo de control, no liberar C y fijar el KPI y los guardrails con su responsable.</a:t>
+              <a:t>Tres decisiones: aprobar el piloto de B desde el próximo corte, no liberar C y fijar KPI y guardrails.</a:t>
             </a:r>
             <a:endParaRPr lang="en-US" sz="1250" dirty="0"/>
           </a:p>
@@ -13919,7 +14326,7 @@
         <p:spPr>
           <a:xfrm>
             <a:off x="457200" y="1828800"/>
-            <a:ext cx="6502116" cy="256032"/>
+            <a:ext cx="6502116" cy="292608"/>
           </a:xfrm>
           <a:prstGeom prst="rect">
             <a:avLst/>
@@ -13946,7 +14353,7 @@
                 <a:ea typeface="Segoe UI" pitchFamily="34" charset="-122"/>
                 <a:cs typeface="Segoe UI" pitchFamily="34" charset="-120"/>
               </a:rPr>
-              <a:t>Tres decisiones para hoy</a:t>
+              <a:t>Tres decisiones</a:t>
             </a:r>
             <a:endParaRPr lang="en-US" sz="1200" dirty="0"/>
           </a:p>
@@ -13960,7 +14367,7 @@
         </p:nvSpPr>
         <p:spPr>
           <a:xfrm>
-            <a:off x="457200" y="2157984"/>
+            <a:off x="457200" y="2121408"/>
             <a:ext cx="457200" cy="548640"/>
           </a:xfrm>
           <a:prstGeom prst="rect">
@@ -13980,17 +14387,17 @@
               <a:buNone/>
             </a:pPr>
             <a:r>
-              <a:rPr lang="en-US" sz="3200" dirty="0">
+              <a:rPr lang="en-US" sz="2800" dirty="0">
                 <a:solidFill>
                   <a:srgbClr val="E35A00"/>
                 </a:solidFill>
-                <a:latin typeface="Bahnschrift" pitchFamily="34" charset="0"/>
-                <a:ea typeface="Bahnschrift" pitchFamily="34" charset="-122"/>
-                <a:cs typeface="Bahnschrift" pitchFamily="34" charset="-120"/>
+                <a:latin typeface="Segoe UI Semibold" pitchFamily="34" charset="0"/>
+                <a:ea typeface="Segoe UI Semibold" pitchFamily="34" charset="-122"/>
+                <a:cs typeface="Segoe UI Semibold" pitchFamily="34" charset="-120"/>
               </a:rPr>
               <a:t>1</a:t>
             </a:r>
-            <a:endParaRPr lang="en-US" sz="3200" dirty="0"/>
+            <a:endParaRPr lang="en-US" sz="2800" dirty="0"/>
           </a:p>
         </p:txBody>
       </p:sp>
@@ -14002,8 +14409,8 @@
         </p:nvSpPr>
         <p:spPr>
           <a:xfrm>
-            <a:off x="1005840" y="2212848"/>
-            <a:ext cx="5953476" cy="603504"/>
+            <a:off x="1005840" y="2176272"/>
+            <a:ext cx="5953476" cy="530352"/>
           </a:xfrm>
           <a:prstGeom prst="rect">
             <a:avLst/>
@@ -14064,7 +14471,7 @@
         </p:nvSpPr>
         <p:spPr>
           <a:xfrm>
-            <a:off x="457200" y="2852928"/>
+            <a:off x="457200" y="2743200"/>
             <a:ext cx="6502116" cy="0"/>
           </a:xfrm>
           <a:prstGeom prst="line">
@@ -14087,7 +14494,7 @@
         </p:nvSpPr>
         <p:spPr>
           <a:xfrm>
-            <a:off x="457200" y="2871216"/>
+            <a:off x="457200" y="2743200"/>
             <a:ext cx="457200" cy="548640"/>
           </a:xfrm>
           <a:prstGeom prst="rect">
@@ -14107,17 +14514,17 @@
               <a:buNone/>
             </a:pPr>
             <a:r>
-              <a:rPr lang="en-US" sz="3200" dirty="0">
+              <a:rPr lang="en-US" sz="2800" dirty="0">
                 <a:solidFill>
                   <a:srgbClr val="E35A00"/>
                 </a:solidFill>
-                <a:latin typeface="Bahnschrift" pitchFamily="34" charset="0"/>
-                <a:ea typeface="Bahnschrift" pitchFamily="34" charset="-122"/>
-                <a:cs typeface="Bahnschrift" pitchFamily="34" charset="-120"/>
+                <a:latin typeface="Segoe UI Semibold" pitchFamily="34" charset="0"/>
+                <a:ea typeface="Segoe UI Semibold" pitchFamily="34" charset="-122"/>
+                <a:cs typeface="Segoe UI Semibold" pitchFamily="34" charset="-120"/>
               </a:rPr>
               <a:t>2</a:t>
             </a:r>
-            <a:endParaRPr lang="en-US" sz="3200" dirty="0"/>
+            <a:endParaRPr lang="en-US" sz="2800" dirty="0"/>
           </a:p>
         </p:txBody>
       </p:sp>
@@ -14129,8 +14536,8 @@
         </p:nvSpPr>
         <p:spPr>
           <a:xfrm>
-            <a:off x="1005840" y="2926080"/>
-            <a:ext cx="5953476" cy="603504"/>
+            <a:off x="1005840" y="2798064"/>
+            <a:ext cx="5953476" cy="530352"/>
           </a:xfrm>
           <a:prstGeom prst="rect">
             <a:avLst/>
@@ -14177,7 +14584,7 @@
                 <a:ea typeface="Segoe UI" pitchFamily="34" charset="-122"/>
                 <a:cs typeface="Segoe UI" pitchFamily="34" charset="-120"/>
               </a:rPr>
-              <a:t>A, tras verificar sus variables; D, con datos del grupo de control.</a:t>
+              <a:t>A, tras verificar variables; D, con datos del piloto.</a:t>
             </a:r>
             <a:endParaRPr lang="en-US" sz="1100" dirty="0"/>
           </a:p>
@@ -14191,7 +14598,7 @@
         </p:nvSpPr>
         <p:spPr>
           <a:xfrm>
-            <a:off x="457200" y="3566160"/>
+            <a:off x="457200" y="3364992"/>
             <a:ext cx="6502116" cy="0"/>
           </a:xfrm>
           <a:prstGeom prst="line">
@@ -14214,7 +14621,7 @@
         </p:nvSpPr>
         <p:spPr>
           <a:xfrm>
-            <a:off x="457200" y="3584448"/>
+            <a:off x="457200" y="3364992"/>
             <a:ext cx="457200" cy="548640"/>
           </a:xfrm>
           <a:prstGeom prst="rect">
@@ -14234,17 +14641,17 @@
               <a:buNone/>
             </a:pPr>
             <a:r>
-              <a:rPr lang="en-US" sz="3200" dirty="0">
+              <a:rPr lang="en-US" sz="2800" dirty="0">
                 <a:solidFill>
                   <a:srgbClr val="E35A00"/>
                 </a:solidFill>
-                <a:latin typeface="Bahnschrift" pitchFamily="34" charset="0"/>
-                <a:ea typeface="Bahnschrift" pitchFamily="34" charset="-122"/>
-                <a:cs typeface="Bahnschrift" pitchFamily="34" charset="-120"/>
+                <a:latin typeface="Segoe UI Semibold" pitchFamily="34" charset="0"/>
+                <a:ea typeface="Segoe UI Semibold" pitchFamily="34" charset="-122"/>
+                <a:cs typeface="Segoe UI Semibold" pitchFamily="34" charset="-120"/>
               </a:rPr>
               <a:t>3</a:t>
             </a:r>
-            <a:endParaRPr lang="en-US" sz="3200" dirty="0"/>
+            <a:endParaRPr lang="en-US" sz="2800" dirty="0"/>
           </a:p>
         </p:txBody>
       </p:sp>
@@ -14256,8 +14663,8 @@
         </p:nvSpPr>
         <p:spPr>
           <a:xfrm>
-            <a:off x="1005840" y="3639312"/>
-            <a:ext cx="5953476" cy="603504"/>
+            <a:off x="1005840" y="3419856"/>
+            <a:ext cx="5953476" cy="530352"/>
           </a:xfrm>
           <a:prstGeom prst="rect">
             <a:avLst/>
@@ -14304,7 +14711,7 @@
                 <a:ea typeface="Segoe UI" pitchFamily="34" charset="-122"/>
                 <a:cs typeface="Segoe UI" pitchFamily="34" charset="-120"/>
               </a:rPr>
-              <a:t>Pesos netos de mora por contacto; cinco límites con umbral y responsable.</a:t>
+              <a:t>KPI neto de mora; cinco límites con responsable.</a:t>
             </a:r>
             <a:endParaRPr lang="en-US" sz="1100" dirty="0"/>
           </a:p>
@@ -14318,8 +14725,8 @@
         </p:nvSpPr>
         <p:spPr>
           <a:xfrm>
-            <a:off x="457200" y="4526280"/>
-            <a:ext cx="6502116" cy="256032"/>
+            <a:off x="457200" y="4078224"/>
+            <a:ext cx="6502116" cy="292608"/>
           </a:xfrm>
           <a:prstGeom prst="rect">
             <a:avLst/>
@@ -14360,8 +14767,8 @@
         </p:nvSpPr>
         <p:spPr>
           <a:xfrm>
-            <a:off x="457200" y="4818888"/>
-            <a:ext cx="6502116" cy="1280160"/>
+            <a:off x="457200" y="4407408"/>
+            <a:ext cx="6502116" cy="1920240"/>
           </a:xfrm>
           <a:prstGeom prst="rect">
             <a:avLst/>
@@ -14419,6 +14826,17 @@
               <a:buChar char="▪"/>
             </a:pPr>
             <a:r>
+              <a:rPr lang="en-US" sz="1100" b="1" dirty="0">
+                <a:solidFill>
+                  <a:srgbClr val="2E2E2E"/>
+                </a:solidFill>
+                <a:latin typeface="Segoe UI" pitchFamily="34" charset="0"/>
+                <a:ea typeface="Segoe UI" pitchFamily="34" charset="-122"/>
+                <a:cs typeface="Segoe UI" pitchFamily="34" charset="-120"/>
+              </a:rPr>
+              <a:t>Auditable: </a:t>
+            </a:r>
+            <a:r>
               <a:rPr lang="en-US" sz="1100" dirty="0">
                 <a:solidFill>
                   <a:srgbClr val="2E2E2E"/>
@@ -14427,7 +14845,42 @@
                 <a:ea typeface="Segoe UI" pitchFamily="34" charset="-122"/>
                 <a:cs typeface="Segoe UI" pitchFamily="34" charset="-120"/>
               </a:rPr>
-              <a:t>Importancia no es causa: solo el grupo de control prueba si llamar cambia el resultado.</a:t>
+              <a:t>ficha del modelo, ficha de la base, verificación de variables, plan de monitoreo y responsables por área.</a:t>
+            </a:r>
+            <a:endParaRPr lang="en-US" sz="1100" dirty="0"/>
+          </a:p>
+          <a:p>
+            <a:pPr marL="152400" indent="-152400">
+              <a:lnSpc>
+                <a:spcPct val="115000"/>
+              </a:lnSpc>
+              <a:spcAft>
+                <a:spcPts val="400"/>
+              </a:spcAft>
+              <a:buSzPct val="100000"/>
+              <a:buChar char="▪"/>
+            </a:pPr>
+            <a:r>
+              <a:rPr lang="en-US" sz="1100" b="1" dirty="0">
+                <a:solidFill>
+                  <a:srgbClr val="2E2E2E"/>
+                </a:solidFill>
+                <a:latin typeface="Segoe UI" pitchFamily="34" charset="0"/>
+                <a:ea typeface="Segoe UI" pitchFamily="34" charset="-122"/>
+                <a:cs typeface="Segoe UI" pitchFamily="34" charset="-120"/>
+              </a:rPr>
+              <a:t>Importancia no es causa: </a:t>
+            </a:r>
+            <a:r>
+              <a:rPr lang="en-US" sz="1100" dirty="0">
+                <a:solidFill>
+                  <a:srgbClr val="2E2E2E"/>
+                </a:solidFill>
+                <a:latin typeface="Segoe UI" pitchFamily="34" charset="0"/>
+                <a:ea typeface="Segoe UI" pitchFamily="34" charset="-122"/>
+                <a:cs typeface="Segoe UI" pitchFamily="34" charset="-120"/>
+              </a:rPr>
+              <a:t>al buró alto se le contactó más (37 % frente a 22 % sin contactar); solo el grupo de control prueba si llamar cambia el resultado.</a:t>
             </a:r>
             <a:endParaRPr lang="en-US" sz="1100" dirty="0"/>
           </a:p>
@@ -14462,7 +14915,7 @@
         <p:spPr>
           <a:xfrm>
             <a:off x="8261787" y="2048256"/>
-            <a:ext cx="3216676" cy="256032"/>
+            <a:ext cx="3216676" cy="292608"/>
           </a:xfrm>
           <a:prstGeom prst="rect">
             <a:avLst/>
@@ -14571,7 +15024,7 @@
                 <a:ea typeface="Segoe UI" pitchFamily="34" charset="-122"/>
                 <a:cs typeface="Segoe UI" pitchFamily="34" charset="-120"/>
               </a:rPr>
-              <a:t>Definir el 12 %, la regla de contacto y el uso del buró.</a:t>
+              <a:t>Definir el 12 %, la regla de contacto y el buró.</a:t>
             </a:r>
             <a:endParaRPr lang="en-US" sz="1100" dirty="0"/>
           </a:p>
@@ -14653,7 +15106,7 @@
                 <a:ea typeface="Segoe UI" pitchFamily="34" charset="-122"/>
                 <a:cs typeface="Segoe UI" pitchFamily="34" charset="-120"/>
               </a:rPr>
-              <a:t>Verificar A y B variable por variable; datos fechados al corte; cuotas.</a:t>
+              <a:t>Verificar A y B; datos fechados al corte; cuotas.</a:t>
             </a:r>
             <a:endParaRPr lang="en-US" sz="1100" dirty="0"/>
           </a:p>
@@ -14735,7 +15188,7 @@
                 <a:ea typeface="Segoe UI" pitchFamily="34" charset="-122"/>
                 <a:cs typeface="Segoe UI" pitchFamily="34" charset="-120"/>
               </a:rPr>
-              <a:t>Piloto con grupo de control y monitoreo semanal.</a:t>
+              <a:t>Piloto y monitoreo semanal.</a:t>
             </a:r>
             <a:endParaRPr lang="en-US" sz="1100" dirty="0"/>
           </a:p>
@@ -14817,7 +15270,7 @@
                 <a:ea typeface="Segoe UI" pitchFamily="34" charset="-122"/>
                 <a:cs typeface="Segoe UI" pitchFamily="34" charset="-120"/>
               </a:rPr>
-              <a:t>Si llamar crea renovaciones, escalar; si no, mantener la herramienta actual.</a:t>
+              <a:t>Escalar si llamar crea renovaciones; si no, mantener la actual.</a:t>
             </a:r>
             <a:endParaRPr lang="en-US" sz="1100" dirty="0"/>
           </a:p>
@@ -14835,8 +15288,8 @@
         </p:nvSpPr>
         <p:spPr>
           <a:xfrm>
-            <a:off x="11274552" y="6473952"/>
-            <a:ext cx="457200" cy="228600"/>
+            <a:off x="11274552" y="6419088"/>
+            <a:ext cx="457200" cy="347472"/>
           </a:xfrm>
           <a:prstGeom prst="rect">
             <a:avLst/>
@@ -14865,7 +15318,7 @@
             <a:pPr algn="r"/>
             <a:fld id="{F7021451-1387-4CA6-816F-3879F97B5CBC}" type="slidenum">
               <a:rPr lang="en-US" b="0"/>
-              <a:t>6</a:t>
+              <a:t>7</a:t>
             </a:fld>
             <a:endParaRPr lang="en-US"/>
           </a:p>
@@ -14879,9 +15332,180 @@
 </p:sld>
 </file>
 
-<file path=ppt/slides/slide7.xml><?xml version="1.0" encoding="utf-8"?>
+<file path=ppt/slides/slide8.xml><?xml version="1.0" encoding="utf-8"?>
 <p:sld xmlns:a="http://schemas.openxmlformats.org/drawingml/2006/main" xmlns:r="http://schemas.openxmlformats.org/officeDocument/2006/relationships" xmlns:p="http://schemas.openxmlformats.org/presentationml/2006/main">
-  <p:cSld name="Slide 7">
+  <p:cSld name="Slide 8">
+    <p:spTree>
+      <p:nvGrpSpPr>
+        <p:cNvPr id="1" name=""/>
+        <p:cNvGrpSpPr/>
+        <p:nvPr/>
+      </p:nvGrpSpPr>
+      <p:grpSpPr>
+        <a:xfrm>
+          <a:off x="0" y="0"/>
+          <a:ext cx="0" cy="0"/>
+          <a:chOff x="0" y="0"/>
+          <a:chExt cx="0" cy="0"/>
+        </a:xfrm>
+      </p:grpSpPr>
+      <p:sp>
+        <p:nvSpPr>
+          <p:cNvPr id="2" name="Shape 0"/>
+          <p:cNvSpPr/>
+          <p:nvPr/>
+        </p:nvSpPr>
+        <p:spPr>
+          <a:xfrm>
+            <a:off x="1412199" y="2011680"/>
+            <a:ext cx="914400" cy="73152"/>
+          </a:xfrm>
+          <a:prstGeom prst="rect">
+            <a:avLst/>
+          </a:prstGeom>
+          <a:solidFill>
+            <a:srgbClr val="FE6A00"/>
+          </a:solidFill>
+          <a:ln/>
+        </p:spPr>
+      </p:sp>
+      <p:sp>
+        <p:nvSpPr>
+          <p:cNvPr id="3" name="Text 1"/>
+          <p:cNvSpPr txBox="1"/>
+          <p:nvPr/>
+        </p:nvSpPr>
+        <p:spPr>
+          <a:xfrm>
+            <a:off x="1412199" y="2240280"/>
+            <a:ext cx="9367114" cy="868680"/>
+          </a:xfrm>
+          <a:prstGeom prst="rect">
+            <a:avLst/>
+          </a:prstGeom>
+          <a:noFill/>
+          <a:ln/>
+        </p:spPr>
+        <p:txBody>
+          <a:bodyPr wrap="square" lIns="0" tIns="0" rIns="0" bIns="0" rtlCol="0" anchor="t"/>
+          <a:lstStyle/>
+          <a:p>
+            <a:pPr marL="0" indent="0">
+              <a:lnSpc>
+                <a:spcPct val="100000"/>
+              </a:lnSpc>
+              <a:buNone/>
+            </a:pPr>
+            <a:r>
+              <a:rPr lang="en-US" sz="4800" dirty="0">
+                <a:solidFill>
+                  <a:srgbClr val="FFFFFF"/>
+                </a:solidFill>
+                <a:latin typeface="Segoe UI Semibold" pitchFamily="34" charset="0"/>
+                <a:ea typeface="Segoe UI Semibold" pitchFamily="34" charset="-122"/>
+                <a:cs typeface="Segoe UI Semibold" pitchFamily="34" charset="-120"/>
+              </a:rPr>
+              <a:t>Gracias</a:t>
+            </a:r>
+            <a:endParaRPr lang="en-US" sz="4800" dirty="0"/>
+          </a:p>
+        </p:txBody>
+      </p:sp>
+      <p:sp>
+        <p:nvSpPr>
+          <p:cNvPr id="4" name="Text 2"/>
+          <p:cNvSpPr txBox="1"/>
+          <p:nvPr/>
+        </p:nvSpPr>
+        <p:spPr>
+          <a:xfrm>
+            <a:off x="1412199" y="3291840"/>
+            <a:ext cx="8412114" cy="868680"/>
+          </a:xfrm>
+          <a:prstGeom prst="rect">
+            <a:avLst/>
+          </a:prstGeom>
+          <a:noFill/>
+          <a:ln/>
+        </p:spPr>
+        <p:txBody>
+          <a:bodyPr wrap="square" lIns="0" tIns="0" rIns="0" bIns="0" rtlCol="0" anchor="t"/>
+          <a:lstStyle/>
+          <a:p>
+            <a:pPr marL="0" indent="0">
+              <a:lnSpc>
+                <a:spcPct val="115000"/>
+              </a:lnSpc>
+              <a:buNone/>
+            </a:pPr>
+            <a:r>
+              <a:rPr lang="en-US" sz="1800" dirty="0">
+                <a:solidFill>
+                  <a:srgbClr val="FFFFFF"/>
+                </a:solidFill>
+                <a:latin typeface="Segoe UI" pitchFamily="34" charset="0"/>
+                <a:ea typeface="Segoe UI" pitchFamily="34" charset="-122"/>
+                <a:cs typeface="Segoe UI" pitchFamily="34" charset="-120"/>
+              </a:rPr>
+              <a:t>Pedimos hoy tres decisiones: aprobar el piloto de B con grupo de control, no liberar C y fijar el KPI y los guardrails con su responsable.</a:t>
+            </a:r>
+            <a:endParaRPr lang="en-US" sz="1800" dirty="0"/>
+          </a:p>
+        </p:txBody>
+      </p:sp>
+      <p:sp>
+        <p:nvSpPr>
+          <p:cNvPr id="5" name="Text 3"/>
+          <p:cNvSpPr txBox="1"/>
+          <p:nvPr/>
+        </p:nvSpPr>
+        <p:spPr>
+          <a:xfrm>
+            <a:off x="1412199" y="4663440"/>
+            <a:ext cx="9367114" cy="365760"/>
+          </a:xfrm>
+          <a:prstGeom prst="rect">
+            <a:avLst/>
+          </a:prstGeom>
+          <a:noFill/>
+          <a:ln/>
+        </p:spPr>
+        <p:txBody>
+          <a:bodyPr wrap="square" lIns="0" tIns="0" rIns="0" bIns="0" rtlCol="0" anchor="t"/>
+          <a:lstStyle/>
+          <a:p>
+            <a:pPr marL="0" indent="0">
+              <a:lnSpc>
+                <a:spcPct val="115000"/>
+              </a:lnSpc>
+              <a:buNone/>
+            </a:pPr>
+            <a:r>
+              <a:rPr lang="en-US" sz="1400" dirty="0">
+                <a:solidFill>
+                  <a:srgbClr val="FFFFFF"/>
+                </a:solidFill>
+                <a:latin typeface="Segoe UI" pitchFamily="34" charset="0"/>
+                <a:ea typeface="Segoe UI" pitchFamily="34" charset="-122"/>
+                <a:cs typeface="Segoe UI" pitchFamily="34" charset="-120"/>
+              </a:rPr>
+              <a:t>Preguntas y discusión. El anexo técnico queda de respaldo.</a:t>
+            </a:r>
+            <a:endParaRPr lang="en-US" sz="1400" dirty="0"/>
+          </a:p>
+        </p:txBody>
+      </p:sp>
+    </p:spTree>
+  </p:cSld>
+  <p:clrMapOvr>
+    <a:masterClrMapping/>
+  </p:clrMapOvr>
+</p:sld>
+</file>
+
+<file path=ppt/slides/slide9.xml><?xml version="1.0" encoding="utf-8"?>
+<p:sld xmlns:a="http://schemas.openxmlformats.org/drawingml/2006/main" xmlns:r="http://schemas.openxmlformats.org/officeDocument/2006/relationships" xmlns:p="http://schemas.openxmlformats.org/presentationml/2006/main">
+  <p:cSld name="Slide 9">
     <p:spTree>
       <p:nvGrpSpPr>
         <p:cNvPr id="1" name=""/>
@@ -14903,13 +15527,13 @@
             <a:spLocks noGrp="1"/>
           </p:cNvSpPr>
           <p:nvPr>
-            <p:ph type="title" idx="102" hasCustomPrompt="1"/>
+            <p:ph type="title" idx="101" hasCustomPrompt="1"/>
           </p:nvPr>
         </p:nvSpPr>
         <p:spPr>
           <a:xfrm>
-            <a:off x="457200" y="347472"/>
-            <a:ext cx="11277295" cy="438912"/>
+            <a:off x="457200" y="310896"/>
+            <a:ext cx="11277295" cy="512064"/>
           </a:xfrm>
           <a:prstGeom prst="rect">
             <a:avLst/>
@@ -14929,11 +15553,11 @@
                 <a:solidFill>
                   <a:srgbClr val="2E2E2E"/>
                 </a:solidFill>
-                <a:latin typeface="Bahnschrift" pitchFamily="34" charset="0"/>
-                <a:ea typeface="Bahnschrift" pitchFamily="34" charset="-122"/>
-                <a:cs typeface="Bahnschrift" pitchFamily="34" charset="-120"/>
+                <a:latin typeface="Segoe UI Semibold" pitchFamily="34" charset="0"/>
+                <a:ea typeface="Segoe UI Semibold" pitchFamily="34" charset="-122"/>
+                <a:cs typeface="Segoe UI Semibold" pitchFamily="34" charset="-120"/>
               </a:rPr>
-              <a:t>Anexo · Soporte técnico: réplica, economía, tamaños de muestra y variables</a:t>
+              <a:t>Anexo · Réplica, economía, tamaños de muestra y variables</a:t>
             </a:r>
             <a:endParaRPr lang="en-US" sz="2400" dirty="0"/>
           </a:p>
@@ -14948,7 +15572,7 @@
         <p:spPr>
           <a:xfrm>
             <a:off x="457200" y="1051560"/>
-            <a:ext cx="6502116" cy="256032"/>
+            <a:ext cx="6502116" cy="292608"/>
           </a:xfrm>
           <a:prstGeom prst="rect">
             <a:avLst/>
@@ -14983,7 +15607,7 @@
       </p:sp>
       <p:graphicFrame>
         <p:nvGraphicFramePr>
-          <p:cNvPr id="8" name="Table 0"/>
+          <p:cNvPr id="10" name="Table 0"/>
           <p:cNvGraphicFramePr>
             <a:graphicFrameLocks noGrp="1"/>
           </p:cNvGraphicFramePr>
@@ -16973,7 +17597,7 @@
                           <a:ea typeface="Segoe UI" pitchFamily="34" charset="-122"/>
                           <a:cs typeface="Segoe UI" pitchFamily="34" charset="-120"/>
                         </a:rPr>
-                        <a:t>LightGBM</a:t>
+                        <a:t>Logística</a:t>
                       </a:r>
                       <a:endParaRPr lang="en-US" sz="950" dirty="0">
                         <a:latin typeface="Segoe UI" charset="0"/>
@@ -17026,7 +17650,7 @@
                           <a:ea typeface="Segoe UI" pitchFamily="34" charset="-122"/>
                           <a:cs typeface="Segoe UI" pitchFamily="34" charset="-120"/>
                         </a:rPr>
-                        <a:t>1,000</a:t>
+                        <a:t>0,997</a:t>
                       </a:r>
                       <a:endParaRPr lang="en-US" sz="950" dirty="0">
                         <a:latin typeface="Segoe UI" charset="0"/>
@@ -17079,7 +17703,7 @@
                           <a:ea typeface="Segoe UI" pitchFamily="34" charset="-122"/>
                           <a:cs typeface="Segoe UI" pitchFamily="34" charset="-120"/>
                         </a:rPr>
-                        <a:t>1,00–1,00</a:t>
+                        <a:t>0,99–1,00</a:t>
                       </a:r>
                       <a:endParaRPr lang="en-US" sz="950" dirty="0">
                         <a:latin typeface="Segoe UI" charset="0"/>
@@ -17132,7 +17756,7 @@
                           <a:ea typeface="Segoe UI" pitchFamily="34" charset="-122"/>
                           <a:cs typeface="Segoe UI" pitchFamily="34" charset="-120"/>
                         </a:rPr>
-                        <a:t>1,00</a:t>
+                        <a:t>0,99</a:t>
                       </a:r>
                       <a:endParaRPr lang="en-US" sz="950" dirty="0">
                         <a:latin typeface="Segoe UI" charset="0"/>
@@ -17185,7 +17809,7 @@
                           <a:ea typeface="Segoe UI" pitchFamily="34" charset="-122"/>
                           <a:cs typeface="Segoe UI" pitchFamily="34" charset="-120"/>
                         </a:rPr>
-                        <a:t>1,00</a:t>
+                        <a:t>1,03</a:t>
                       </a:r>
                       <a:endParaRPr lang="en-US" sz="950" dirty="0">
                         <a:latin typeface="Segoe UI" charset="0"/>
@@ -17238,7 +17862,7 @@
                           <a:ea typeface="Segoe UI" pitchFamily="34" charset="-122"/>
                           <a:cs typeface="Segoe UI" pitchFamily="34" charset="-120"/>
                         </a:rPr>
-                        <a:t>0,000</a:t>
+                        <a:t>0,015</a:t>
                       </a:r>
                       <a:endParaRPr lang="en-US" sz="950" dirty="0">
                         <a:latin typeface="Segoe UI" charset="0"/>
@@ -17335,7 +17959,7 @@
         <p:spPr>
           <a:xfrm>
             <a:off x="7325076" y="1051560"/>
-            <a:ext cx="4409420" cy="256032"/>
+            <a:ext cx="4409420" cy="292608"/>
           </a:xfrm>
           <a:prstGeom prst="rect">
             <a:avLst/>
@@ -17370,7 +17994,7 @@
       </p:sp>
       <p:graphicFrame>
         <p:nvGraphicFramePr>
-          <p:cNvPr id="15" name="Table 1"/>
+          <p:cNvPr id="19" name="Table 1"/>
           <p:cNvGraphicFramePr>
             <a:graphicFrameLocks noGrp="1"/>
           </p:cNvGraphicFramePr>
@@ -19354,7 +19978,7 @@
       </p:graphicFrame>
       <p:sp>
         <p:nvSpPr>
-          <p:cNvPr id="4" name="Text 4"/>
+          <p:cNvPr id="8" name="Text 4"/>
           <p:cNvSpPr txBox="1"/>
           <p:nvPr/>
         </p:nvSpPr>
@@ -19419,14 +20043,14 @@
       </p:sp>
       <p:sp>
         <p:nvSpPr>
-          <p:cNvPr id="10" name="Text 6"/>
+          <p:cNvPr id="4" name="Text 6"/>
           <p:cNvSpPr txBox="1"/>
           <p:nvPr/>
         </p:nvSpPr>
         <p:spPr>
           <a:xfrm>
             <a:off x="457200" y="3858768"/>
-            <a:ext cx="5547116" cy="256032"/>
+            <a:ext cx="5547116" cy="292608"/>
           </a:xfrm>
           <a:prstGeom prst="rect">
             <a:avLst/>
@@ -19461,7 +20085,7 @@
       </p:sp>
       <p:graphicFrame>
         <p:nvGraphicFramePr>
-          <p:cNvPr id="22" name="Table 2"/>
+          <p:cNvPr id="28" name="Table 2"/>
           <p:cNvGraphicFramePr>
             <a:graphicFrameLocks noGrp="1"/>
           </p:cNvGraphicFramePr>
@@ -20703,7 +21327,7 @@
         <p:spPr>
           <a:xfrm>
             <a:off x="6187196" y="3858768"/>
-            <a:ext cx="5547116" cy="256032"/>
+            <a:ext cx="5547116" cy="292608"/>
           </a:xfrm>
           <a:prstGeom prst="rect">
             <a:avLst/>
@@ -20738,7 +21362,7 @@
       </p:sp>
       <p:graphicFrame>
         <p:nvGraphicFramePr>
-          <p:cNvPr id="29" name="Table 3"/>
+          <p:cNvPr id="37" name="Table 3"/>
           <p:cNvGraphicFramePr>
             <a:graphicFrameLocks noGrp="1"/>
           </p:cNvGraphicFramePr>
@@ -21609,8 +22233,8 @@
         </p:nvSpPr>
         <p:spPr>
           <a:xfrm>
-            <a:off x="11274552" y="6473952"/>
-            <a:ext cx="457200" cy="228600"/>
+            <a:off x="11274552" y="6419088"/>
+            <a:ext cx="457200" cy="347472"/>
           </a:xfrm>
           <a:prstGeom prst="rect">
             <a:avLst/>
@@ -21639,7 +22263,7 @@
             <a:pPr algn="r"/>
             <a:fld id="{F7021451-1387-4CA6-816F-3879F97B5CBC}" type="slidenum">
               <a:rPr lang="en-US" b="0"/>
-              <a:t>7</a:t>
+              <a:t>9</a:t>
             </a:fld>
             <a:endParaRPr lang="en-US"/>
           </a:p>
@@ -21696,7 +22320,7 @@
     </a:clrScheme>
     <a:fontScheme name="Banco W documento">
       <a:majorFont>
-        <a:latin typeface="Bahnschrift"/>
+        <a:latin typeface="Segoe UI Semibold"/>
         <a:ea typeface=""/>
         <a:cs typeface=""/>
         <a:font script="Jpan" typeface="游ゴシック Light"/>

</xml_diff>